<commit_message>
Restore stacked-window slide 1; feed graphics deck shows the three windows side by side
Co-Authored-By: Claude Sonnet 5.5 <noreply@anthropic.com>
Claude-Session: https://claude.ai/code/session_0139kriXJ67p3UvpR2gsSR9G
</commit_message>
<xml_diff>
--- a/videoslides/cleverbox-feed-grafiken.pptx
+++ b/videoslides/cleverbox-feed-grafiken.pptx
@@ -593,7 +593,7 @@
           <a:p>
             <a:r>
               <a:rPr lang="en-US" dirty="0"/>
-              <a:t>Einzelgrafik 1: Lenas Feed – gleiche Position wie in der Übersicht, für Animation</a:t>
+              <a:t>Einzelgrafik 1: Lenas Feed – gleiche Position wie in der Übersicht</a:t>
             </a:r>
             <a:endParaRPr lang="en-US" dirty="0"/>
           </a:p>
@@ -681,7 +681,7 @@
           <a:p>
             <a:r>
               <a:rPr lang="en-US" dirty="0"/>
-              <a:t>Einzelgrafik 2: Jonas’ Feed – gleiche Position wie in der Übersicht, für Animation</a:t>
+              <a:t>Einzelgrafik 2: Jonas’ Feed – gleiche Position wie in der Übersicht</a:t>
             </a:r>
             <a:endParaRPr lang="en-US" dirty="0"/>
           </a:p>
@@ -769,7 +769,7 @@
           <a:p>
             <a:r>
               <a:rPr lang="en-US" dirty="0"/>
-              <a:t>Einzelgrafik 3: Dein Feed – gleiche Position wie in der Übersicht, für Animation</a:t>
+              <a:t>Einzelgrafik 3: Dein Feed – gleiche Position wie in der Übersicht</a:t>
             </a:r>
             <a:endParaRPr lang="en-US" dirty="0"/>
           </a:p>
@@ -1392,20 +1392,20 @@
         </p:nvSpPr>
         <p:spPr>
           <a:xfrm>
-            <a:off x="2591410" y="685800"/>
-            <a:ext cx="1787652" cy="4942332"/>
+            <a:off x="518008" y="1508760"/>
+            <a:ext cx="3474720" cy="3840480"/>
           </a:xfrm>
           <a:prstGeom prst="roundRect">
             <a:avLst>
-              <a:gd name="adj" fmla="val 15345"/>
+              <a:gd name="adj" fmla="val 3158"/>
             </a:avLst>
           </a:prstGeom>
           <a:solidFill>
-            <a:srgbClr val="12301A"/>
-          </a:solidFill>
-          <a:ln w="12700">
-            <a:solidFill>
-              <a:srgbClr val="12301A"/>
+            <a:srgbClr val="FBFFF4"/>
+          </a:solidFill>
+          <a:ln w="15875">
+            <a:solidFill>
+              <a:srgbClr val="B8D98A"/>
             </a:solidFill>
             <a:prstDash val="solid"/>
           </a:ln>
@@ -1419,20 +1419,20 @@
         </p:nvSpPr>
         <p:spPr>
           <a:xfrm>
-            <a:off x="2682850" y="777240"/>
-            <a:ext cx="1604772" cy="4759452"/>
+            <a:off x="518008" y="1508760"/>
+            <a:ext cx="3474720" cy="822960"/>
           </a:xfrm>
           <a:prstGeom prst="roundRect">
             <a:avLst>
-              <a:gd name="adj" fmla="val 12536"/>
+              <a:gd name="adj" fmla="val 13333"/>
             </a:avLst>
           </a:prstGeom>
           <a:solidFill>
-            <a:srgbClr val="FBFFF4"/>
+            <a:srgbClr val="12301A"/>
           </a:solidFill>
           <a:ln w="12700">
             <a:solidFill>
-              <a:srgbClr val="FBFFF4"/>
+              <a:srgbClr val="12301A"/>
             </a:solidFill>
             <a:prstDash val="solid"/>
           </a:ln>
@@ -1446,60 +1446,126 @@
         </p:nvSpPr>
         <p:spPr>
           <a:xfrm>
-            <a:off x="2801722" y="1001268"/>
-            <a:ext cx="1367028" cy="1261872"/>
+            <a:off x="527152" y="1920240"/>
+            <a:ext cx="3456432" cy="457200"/>
+          </a:xfrm>
+          <a:prstGeom prst="rect">
+            <a:avLst/>
+          </a:prstGeom>
+          <a:solidFill>
+            <a:srgbClr val="DDF3B8"/>
+          </a:solidFill>
+          <a:ln w="12700">
+            <a:solidFill>
+              <a:srgbClr val="DDF3B8"/>
+            </a:solidFill>
+            <a:prstDash val="solid"/>
+          </a:ln>
+        </p:spPr>
+      </p:sp>
+      <p:sp>
+        <p:nvSpPr>
+          <p:cNvPr id="6" name="Text 3"/>
+          <p:cNvSpPr txBox="1"/>
+          <p:nvPr/>
+        </p:nvSpPr>
+        <p:spPr>
+          <a:xfrm>
+            <a:off x="1798168" y="1563624"/>
+            <a:ext cx="2011680" cy="310896"/>
+          </a:xfrm>
+          <a:prstGeom prst="rect">
+            <a:avLst/>
+          </a:prstGeom>
+          <a:noFill/>
+          <a:ln/>
+        </p:spPr>
+        <p:txBody>
+          <a:bodyPr wrap="square" lIns="0" tIns="0" rIns="0" bIns="0" rtlCol="0" anchor="ctr"/>
+          <a:lstStyle/>
+          <a:p>
+            <a:pPr algn="r" indent="0" marL="0">
+              <a:buNone/>
+            </a:pPr>
+            <a:r>
+              <a:rPr lang="en-US" sz="1300" dirty="0">
+                <a:solidFill>
+                  <a:srgbClr val="FBFFF4"/>
+                </a:solidFill>
+                <a:latin typeface="Poppins" pitchFamily="34" charset="0"/>
+                <a:ea typeface="Poppins" pitchFamily="34" charset="-122"/>
+                <a:cs typeface="Poppins" pitchFamily="34" charset="-120"/>
+              </a:rPr>
+              <a:t>Für dich</a:t>
+            </a:r>
+            <a:endParaRPr lang="en-US" sz="1300" dirty="0"/>
+          </a:p>
+        </p:txBody>
+      </p:sp>
+      <p:sp>
+        <p:nvSpPr>
+          <p:cNvPr id="7" name="Shape 4"/>
+          <p:cNvSpPr/>
+          <p:nvPr/>
+        </p:nvSpPr>
+        <p:spPr>
+          <a:xfrm>
+            <a:off x="700888" y="1965960"/>
+            <a:ext cx="1920240" cy="411480"/>
           </a:xfrm>
           <a:prstGeom prst="roundRect">
             <a:avLst>
-              <a:gd name="adj" fmla="val 8696"/>
+              <a:gd name="adj" fmla="val 17778"/>
             </a:avLst>
           </a:prstGeom>
           <a:solidFill>
+            <a:srgbClr val="FBFFF4"/>
+          </a:solidFill>
+          <a:ln w="12700">
+            <a:solidFill>
+              <a:srgbClr val="FBFFF4"/>
+            </a:solidFill>
+            <a:prstDash val="solid"/>
+          </a:ln>
+        </p:spPr>
+      </p:sp>
+      <p:sp>
+        <p:nvSpPr>
+          <p:cNvPr id="8" name="Shape 5"/>
+          <p:cNvSpPr/>
+          <p:nvPr/>
+        </p:nvSpPr>
+        <p:spPr>
+          <a:xfrm>
+            <a:off x="828904" y="2093976"/>
+            <a:ext cx="146304" cy="146304"/>
+          </a:xfrm>
+          <a:prstGeom prst="roundRect">
+            <a:avLst>
+              <a:gd name="adj" fmla="val 18750"/>
+            </a:avLst>
+          </a:prstGeom>
+          <a:solidFill>
             <a:srgbClr val="DDF3B8"/>
           </a:solidFill>
-          <a:ln w="12700">
-            <a:solidFill>
-              <a:srgbClr val="DDF3B8"/>
-            </a:solidFill>
-            <a:prstDash val="solid"/>
-          </a:ln>
-        </p:spPr>
-      </p:sp>
-      <p:sp>
-        <p:nvSpPr>
-          <p:cNvPr id="6" name="Shape 3"/>
-          <p:cNvSpPr/>
-          <p:nvPr/>
-        </p:nvSpPr>
-        <p:spPr>
-          <a:xfrm>
-            <a:off x="2991002" y="1190549"/>
-            <a:ext cx="420624" cy="378562"/>
-          </a:xfrm>
-          <a:prstGeom prst="heart">
-            <a:avLst/>
-          </a:prstGeom>
-          <a:solidFill>
-            <a:srgbClr val="26720A"/>
-          </a:solidFill>
-          <a:ln w="12700">
-            <a:solidFill>
-              <a:srgbClr val="26720A"/>
-            </a:solidFill>
-            <a:prstDash val="solid"/>
-          </a:ln>
-        </p:spPr>
-      </p:sp>
-      <p:sp>
-        <p:nvSpPr>
-          <p:cNvPr id="7" name="Text 4"/>
+          <a:ln w="6350">
+            <a:solidFill>
+              <a:srgbClr val="B8D98A"/>
+            </a:solidFill>
+            <a:prstDash val="solid"/>
+          </a:ln>
+        </p:spPr>
+      </p:sp>
+      <p:sp>
+        <p:nvSpPr>
+          <p:cNvPr id="9" name="Text 6"/>
           <p:cNvSpPr txBox="1"/>
           <p:nvPr/>
         </p:nvSpPr>
         <p:spPr>
           <a:xfrm>
-            <a:off x="2927909" y="1653235"/>
-            <a:ext cx="1114654" cy="578358"/>
+            <a:off x="1066648" y="1965960"/>
+            <a:ext cx="1508760" cy="411480"/>
           </a:xfrm>
           <a:prstGeom prst="rect">
             <a:avLst/>
@@ -1512,6 +1578,111 @@
           <a:lstStyle/>
           <a:p>
             <a:pPr indent="0" marL="0">
+              <a:buNone/>
+            </a:pPr>
+            <a:r>
+              <a:rPr lang="en-US" sz="1300" dirty="0">
+                <a:solidFill>
+                  <a:srgbClr val="0E1F0C"/>
+                </a:solidFill>
+                <a:latin typeface="Poppins" pitchFamily="34" charset="0"/>
+                <a:ea typeface="Poppins" pitchFamily="34" charset="-122"/>
+                <a:cs typeface="Poppins" pitchFamily="34" charset="-120"/>
+              </a:rPr>
+              <a:t>Lenas Feed</a:t>
+            </a:r>
+            <a:endParaRPr lang="en-US" sz="1300" dirty="0"/>
+          </a:p>
+        </p:txBody>
+      </p:sp>
+      <p:sp>
+        <p:nvSpPr>
+          <p:cNvPr id="10" name="Text 7"/>
+          <p:cNvSpPr txBox="1"/>
+          <p:nvPr/>
+        </p:nvSpPr>
+        <p:spPr>
+          <a:xfrm>
+            <a:off x="746608" y="2606040"/>
+            <a:ext cx="3017520" cy="457200"/>
+          </a:xfrm>
+          <a:prstGeom prst="rect">
+            <a:avLst/>
+          </a:prstGeom>
+          <a:noFill/>
+          <a:ln/>
+        </p:spPr>
+        <p:txBody>
+          <a:bodyPr wrap="square" lIns="0" tIns="0" rIns="0" bIns="0" rtlCol="0" anchor="t"/>
+          <a:lstStyle/>
+          <a:p>
+            <a:pPr indent="0" marL="0">
+              <a:buNone/>
+            </a:pPr>
+            <a:r>
+              <a:rPr lang="en-US" sz="2200" b="1" dirty="0">
+                <a:solidFill>
+                  <a:srgbClr val="0E1F0C"/>
+                </a:solidFill>
+                <a:latin typeface="Poppins" pitchFamily="34" charset="0"/>
+                <a:ea typeface="Poppins" pitchFamily="34" charset="-122"/>
+                <a:cs typeface="Poppins" pitchFamily="34" charset="-120"/>
+              </a:rPr>
+              <a:t>Lenas Feed</a:t>
+            </a:r>
+            <a:endParaRPr lang="en-US" sz="2200" dirty="0"/>
+          </a:p>
+        </p:txBody>
+      </p:sp>
+      <p:sp>
+        <p:nvSpPr>
+          <p:cNvPr id="11" name="Shape 8"/>
+          <p:cNvSpPr/>
+          <p:nvPr/>
+        </p:nvSpPr>
+        <p:spPr>
+          <a:xfrm>
+            <a:off x="746608" y="3200400"/>
+            <a:ext cx="1554480" cy="457200"/>
+          </a:xfrm>
+          <a:prstGeom prst="roundRect">
+            <a:avLst>
+              <a:gd name="adj" fmla="val 16000"/>
+            </a:avLst>
+          </a:prstGeom>
+          <a:solidFill>
+            <a:srgbClr val="B1FF37"/>
+          </a:solidFill>
+          <a:ln w="12700">
+            <a:solidFill>
+              <a:srgbClr val="B1FF37"/>
+            </a:solidFill>
+            <a:prstDash val="solid"/>
+          </a:ln>
+        </p:spPr>
+      </p:sp>
+      <p:sp>
+        <p:nvSpPr>
+          <p:cNvPr id="12" name="Text 9"/>
+          <p:cNvSpPr txBox="1"/>
+          <p:nvPr/>
+        </p:nvSpPr>
+        <p:spPr>
+          <a:xfrm>
+            <a:off x="746608" y="3200400"/>
+            <a:ext cx="1554480" cy="457200"/>
+          </a:xfrm>
+          <a:prstGeom prst="rect">
+            <a:avLst/>
+          </a:prstGeom>
+          <a:noFill/>
+          <a:ln/>
+        </p:spPr>
+        <p:txBody>
+          <a:bodyPr wrap="square" lIns="0" tIns="0" rIns="0" bIns="0" rtlCol="0" anchor="ctr"/>
+          <a:lstStyle/>
+          <a:p>
+            <a:pPr algn="ctr" indent="0" marL="0">
               <a:buNone/>
             </a:pPr>
             <a:r>
@@ -1523,7 +1694,7 @@
                 <a:ea typeface="Poppins" pitchFamily="34" charset="-122"/>
                 <a:cs typeface="Poppins" pitchFamily="34" charset="-120"/>
               </a:rPr>
-              <a:t>Tanz-Challenge</a:t>
+              <a:t>Tanzvideos</a:t>
             </a:r>
             <a:endParaRPr lang="en-US" sz="1400" dirty="0"/>
           </a:p>
@@ -1531,66 +1702,41 @@
       </p:sp>
       <p:sp>
         <p:nvSpPr>
-          <p:cNvPr id="8" name="Shape 5"/>
-          <p:cNvSpPr/>
-          <p:nvPr/>
-        </p:nvSpPr>
-        <p:spPr>
-          <a:xfrm>
-            <a:off x="2801722" y="2473452"/>
-            <a:ext cx="1367028" cy="1261872"/>
+          <p:cNvPr id="13" name="Shape 10"/>
+          <p:cNvSpPr/>
+          <p:nvPr/>
+        </p:nvSpPr>
+        <p:spPr>
+          <a:xfrm>
+            <a:off x="2438248" y="3200400"/>
+            <a:ext cx="1188720" cy="457200"/>
           </a:xfrm>
           <a:prstGeom prst="roundRect">
             <a:avLst>
-              <a:gd name="adj" fmla="val 8696"/>
+              <a:gd name="adj" fmla="val 16000"/>
             </a:avLst>
           </a:prstGeom>
           <a:solidFill>
-            <a:srgbClr val="DDF3B8"/>
+            <a:srgbClr val="B1FF37"/>
           </a:solidFill>
           <a:ln w="12700">
             <a:solidFill>
-              <a:srgbClr val="DDF3B8"/>
-            </a:solidFill>
-            <a:prstDash val="solid"/>
-          </a:ln>
-        </p:spPr>
-      </p:sp>
-      <p:sp>
-        <p:nvSpPr>
-          <p:cNvPr id="9" name="Shape 6"/>
-          <p:cNvSpPr/>
-          <p:nvPr/>
-        </p:nvSpPr>
-        <p:spPr>
-          <a:xfrm>
-            <a:off x="2991002" y="2662733"/>
-            <a:ext cx="420624" cy="378562"/>
-          </a:xfrm>
-          <a:prstGeom prst="heart">
-            <a:avLst/>
-          </a:prstGeom>
-          <a:solidFill>
-            <a:srgbClr val="26720A"/>
-          </a:solidFill>
-          <a:ln w="12700">
-            <a:solidFill>
-              <a:srgbClr val="26720A"/>
-            </a:solidFill>
-            <a:prstDash val="solid"/>
-          </a:ln>
-        </p:spPr>
-      </p:sp>
-      <p:sp>
-        <p:nvSpPr>
-          <p:cNvPr id="10" name="Text 7"/>
+              <a:srgbClr val="B1FF37"/>
+            </a:solidFill>
+            <a:prstDash val="solid"/>
+          </a:ln>
+        </p:spPr>
+      </p:sp>
+      <p:sp>
+        <p:nvSpPr>
+          <p:cNvPr id="14" name="Text 11"/>
           <p:cNvSpPr txBox="1"/>
           <p:nvPr/>
         </p:nvSpPr>
         <p:spPr>
           <a:xfrm>
-            <a:off x="2927909" y="3125419"/>
-            <a:ext cx="1114654" cy="578358"/>
+            <a:off x="2438248" y="3200400"/>
+            <a:ext cx="1188720" cy="457200"/>
           </a:xfrm>
           <a:prstGeom prst="rect">
             <a:avLst/>
@@ -1602,7 +1748,7 @@
           <a:bodyPr wrap="square" lIns="0" tIns="0" rIns="0" bIns="0" rtlCol="0" anchor="ctr"/>
           <a:lstStyle/>
           <a:p>
-            <a:pPr indent="0" marL="0">
+            <a:pPr algn="ctr" indent="0" marL="0">
               <a:buNone/>
             </a:pPr>
             <a:r>
@@ -1614,7 +1760,7 @@
                 <a:ea typeface="Poppins" pitchFamily="34" charset="-122"/>
                 <a:cs typeface="Poppins" pitchFamily="34" charset="-120"/>
               </a:rPr>
-              <a:t>Choreo lernen</a:t>
+              <a:t>Choreo</a:t>
             </a:r>
             <a:endParaRPr lang="en-US" sz="1400" dirty="0"/>
           </a:p>
@@ -1622,66 +1768,41 @@
       </p:sp>
       <p:sp>
         <p:nvSpPr>
-          <p:cNvPr id="11" name="Shape 8"/>
-          <p:cNvSpPr/>
-          <p:nvPr/>
-        </p:nvSpPr>
-        <p:spPr>
-          <a:xfrm>
-            <a:off x="2801722" y="3945636"/>
-            <a:ext cx="1367028" cy="1261872"/>
+          <p:cNvPr id="15" name="Shape 12"/>
+          <p:cNvSpPr/>
+          <p:nvPr/>
+        </p:nvSpPr>
+        <p:spPr>
+          <a:xfrm>
+            <a:off x="746608" y="3794760"/>
+            <a:ext cx="1645920" cy="457200"/>
           </a:xfrm>
           <a:prstGeom prst="roundRect">
             <a:avLst>
-              <a:gd name="adj" fmla="val 8696"/>
+              <a:gd name="adj" fmla="val 16000"/>
             </a:avLst>
           </a:prstGeom>
           <a:solidFill>
-            <a:srgbClr val="DDF3B8"/>
+            <a:srgbClr val="B1FF37"/>
           </a:solidFill>
           <a:ln w="12700">
             <a:solidFill>
-              <a:srgbClr val="DDF3B8"/>
-            </a:solidFill>
-            <a:prstDash val="solid"/>
-          </a:ln>
-        </p:spPr>
-      </p:sp>
-      <p:sp>
-        <p:nvSpPr>
-          <p:cNvPr id="12" name="Shape 9"/>
-          <p:cNvSpPr/>
-          <p:nvPr/>
-        </p:nvSpPr>
-        <p:spPr>
-          <a:xfrm>
-            <a:off x="2991002" y="4134917"/>
-            <a:ext cx="420624" cy="378562"/>
-          </a:xfrm>
-          <a:prstGeom prst="heart">
-            <a:avLst/>
-          </a:prstGeom>
-          <a:solidFill>
-            <a:srgbClr val="26720A"/>
-          </a:solidFill>
-          <a:ln w="12700">
-            <a:solidFill>
-              <a:srgbClr val="26720A"/>
-            </a:solidFill>
-            <a:prstDash val="solid"/>
-          </a:ln>
-        </p:spPr>
-      </p:sp>
-      <p:sp>
-        <p:nvSpPr>
-          <p:cNvPr id="13" name="Text 10"/>
+              <a:srgbClr val="B1FF37"/>
+            </a:solidFill>
+            <a:prstDash val="solid"/>
+          </a:ln>
+        </p:spPr>
+      </p:sp>
+      <p:sp>
+        <p:nvSpPr>
+          <p:cNvPr id="16" name="Text 13"/>
           <p:cNvSpPr txBox="1"/>
           <p:nvPr/>
         </p:nvSpPr>
         <p:spPr>
           <a:xfrm>
-            <a:off x="2927909" y="4597603"/>
-            <a:ext cx="1114654" cy="578358"/>
+            <a:off x="746608" y="3794760"/>
+            <a:ext cx="1645920" cy="457200"/>
           </a:xfrm>
           <a:prstGeom prst="rect">
             <a:avLst/>
@@ -1693,7 +1814,7 @@
           <a:bodyPr wrap="square" lIns="0" tIns="0" rIns="0" bIns="0" rtlCol="0" anchor="ctr"/>
           <a:lstStyle/>
           <a:p>
-            <a:pPr indent="0" marL="0">
+            <a:pPr algn="ctr" indent="0" marL="0">
               <a:buNone/>
             </a:pPr>
             <a:r>
@@ -1713,14 +1834,14 @@
       </p:sp>
       <p:sp>
         <p:nvSpPr>
-          <p:cNvPr id="14" name="Text 11"/>
+          <p:cNvPr id="17" name="Text 14"/>
           <p:cNvSpPr txBox="1"/>
           <p:nvPr/>
         </p:nvSpPr>
         <p:spPr>
           <a:xfrm>
-            <a:off x="2408530" y="5811012"/>
-            <a:ext cx="2153412" cy="411480"/>
+            <a:off x="746608" y="4754880"/>
+            <a:ext cx="3017520" cy="457200"/>
           </a:xfrm>
           <a:prstGeom prst="rect">
             <a:avLst/>
@@ -1732,11 +1853,222 @@
           <a:bodyPr wrap="square" lIns="0" tIns="0" rIns="0" bIns="0" rtlCol="0" anchor="t"/>
           <a:lstStyle/>
           <a:p>
-            <a:pPr algn="ctr" indent="0" marL="0">
+            <a:pPr indent="0" marL="0">
               <a:buNone/>
             </a:pPr>
             <a:r>
-              <a:rPr lang="en-US" sz="2000" b="1" dirty="0">
+              <a:rPr lang="en-US" sz="1400" dirty="0">
+                <a:solidFill>
+                  <a:srgbClr val="5B6B50"/>
+                </a:solidFill>
+                <a:latin typeface="Poppins" pitchFamily="34" charset="0"/>
+                <a:ea typeface="Poppins" pitchFamily="34" charset="-122"/>
+                <a:cs typeface="Poppins" pitchFamily="34" charset="-120"/>
+              </a:rPr>
+              <a:t>Immer wieder Tanz.</a:t>
+            </a:r>
+            <a:endParaRPr lang="en-US" sz="1400" dirty="0"/>
+          </a:p>
+        </p:txBody>
+      </p:sp>
+      <p:sp>
+        <p:nvSpPr>
+          <p:cNvPr id="18" name="Shape 15"/>
+          <p:cNvSpPr/>
+          <p:nvPr/>
+        </p:nvSpPr>
+        <p:spPr>
+          <a:xfrm>
+            <a:off x="4358488" y="1508760"/>
+            <a:ext cx="3474720" cy="3840480"/>
+          </a:xfrm>
+          <a:prstGeom prst="roundRect">
+            <a:avLst>
+              <a:gd name="adj" fmla="val 3158"/>
+            </a:avLst>
+          </a:prstGeom>
+          <a:solidFill>
+            <a:srgbClr val="FBFFF4"/>
+          </a:solidFill>
+          <a:ln w="15875">
+            <a:solidFill>
+              <a:srgbClr val="B8D98A"/>
+            </a:solidFill>
+            <a:prstDash val="solid"/>
+          </a:ln>
+        </p:spPr>
+      </p:sp>
+      <p:sp>
+        <p:nvSpPr>
+          <p:cNvPr id="19" name="Shape 16"/>
+          <p:cNvSpPr/>
+          <p:nvPr/>
+        </p:nvSpPr>
+        <p:spPr>
+          <a:xfrm>
+            <a:off x="4358488" y="1508760"/>
+            <a:ext cx="3474720" cy="822960"/>
+          </a:xfrm>
+          <a:prstGeom prst="roundRect">
+            <a:avLst>
+              <a:gd name="adj" fmla="val 13333"/>
+            </a:avLst>
+          </a:prstGeom>
+          <a:solidFill>
+            <a:srgbClr val="12301A"/>
+          </a:solidFill>
+          <a:ln w="12700">
+            <a:solidFill>
+              <a:srgbClr val="12301A"/>
+            </a:solidFill>
+            <a:prstDash val="solid"/>
+          </a:ln>
+        </p:spPr>
+      </p:sp>
+      <p:sp>
+        <p:nvSpPr>
+          <p:cNvPr id="20" name="Shape 17"/>
+          <p:cNvSpPr/>
+          <p:nvPr/>
+        </p:nvSpPr>
+        <p:spPr>
+          <a:xfrm>
+            <a:off x="4367632" y="1920240"/>
+            <a:ext cx="3456432" cy="457200"/>
+          </a:xfrm>
+          <a:prstGeom prst="rect">
+            <a:avLst/>
+          </a:prstGeom>
+          <a:solidFill>
+            <a:srgbClr val="DDF3B8"/>
+          </a:solidFill>
+          <a:ln w="12700">
+            <a:solidFill>
+              <a:srgbClr val="DDF3B8"/>
+            </a:solidFill>
+            <a:prstDash val="solid"/>
+          </a:ln>
+        </p:spPr>
+      </p:sp>
+      <p:sp>
+        <p:nvSpPr>
+          <p:cNvPr id="21" name="Text 18"/>
+          <p:cNvSpPr txBox="1"/>
+          <p:nvPr/>
+        </p:nvSpPr>
+        <p:spPr>
+          <a:xfrm>
+            <a:off x="5638648" y="1563624"/>
+            <a:ext cx="2011680" cy="310896"/>
+          </a:xfrm>
+          <a:prstGeom prst="rect">
+            <a:avLst/>
+          </a:prstGeom>
+          <a:noFill/>
+          <a:ln/>
+        </p:spPr>
+        <p:txBody>
+          <a:bodyPr wrap="square" lIns="0" tIns="0" rIns="0" bIns="0" rtlCol="0" anchor="ctr"/>
+          <a:lstStyle/>
+          <a:p>
+            <a:pPr algn="r" indent="0" marL="0">
+              <a:buNone/>
+            </a:pPr>
+            <a:r>
+              <a:rPr lang="en-US" sz="1300" dirty="0">
+                <a:solidFill>
+                  <a:srgbClr val="FBFFF4"/>
+                </a:solidFill>
+                <a:latin typeface="Poppins" pitchFamily="34" charset="0"/>
+                <a:ea typeface="Poppins" pitchFamily="34" charset="-122"/>
+                <a:cs typeface="Poppins" pitchFamily="34" charset="-120"/>
+              </a:rPr>
+              <a:t>Für dich</a:t>
+            </a:r>
+            <a:endParaRPr lang="en-US" sz="1300" dirty="0"/>
+          </a:p>
+        </p:txBody>
+      </p:sp>
+      <p:sp>
+        <p:nvSpPr>
+          <p:cNvPr id="22" name="Shape 19"/>
+          <p:cNvSpPr/>
+          <p:nvPr/>
+        </p:nvSpPr>
+        <p:spPr>
+          <a:xfrm>
+            <a:off x="4541368" y="1965960"/>
+            <a:ext cx="1920240" cy="411480"/>
+          </a:xfrm>
+          <a:prstGeom prst="roundRect">
+            <a:avLst>
+              <a:gd name="adj" fmla="val 17778"/>
+            </a:avLst>
+          </a:prstGeom>
+          <a:solidFill>
+            <a:srgbClr val="FBFFF4"/>
+          </a:solidFill>
+          <a:ln w="12700">
+            <a:solidFill>
+              <a:srgbClr val="FBFFF4"/>
+            </a:solidFill>
+            <a:prstDash val="solid"/>
+          </a:ln>
+        </p:spPr>
+      </p:sp>
+      <p:sp>
+        <p:nvSpPr>
+          <p:cNvPr id="23" name="Shape 20"/>
+          <p:cNvSpPr/>
+          <p:nvPr/>
+        </p:nvSpPr>
+        <p:spPr>
+          <a:xfrm>
+            <a:off x="4669384" y="2093976"/>
+            <a:ext cx="146304" cy="146304"/>
+          </a:xfrm>
+          <a:prstGeom prst="roundRect">
+            <a:avLst>
+              <a:gd name="adj" fmla="val 18750"/>
+            </a:avLst>
+          </a:prstGeom>
+          <a:solidFill>
+            <a:srgbClr val="DDF3B8"/>
+          </a:solidFill>
+          <a:ln w="6350">
+            <a:solidFill>
+              <a:srgbClr val="B8D98A"/>
+            </a:solidFill>
+            <a:prstDash val="solid"/>
+          </a:ln>
+        </p:spPr>
+      </p:sp>
+      <p:sp>
+        <p:nvSpPr>
+          <p:cNvPr id="24" name="Text 21"/>
+          <p:cNvSpPr txBox="1"/>
+          <p:nvPr/>
+        </p:nvSpPr>
+        <p:spPr>
+          <a:xfrm>
+            <a:off x="4907128" y="1965960"/>
+            <a:ext cx="1508760" cy="411480"/>
+          </a:xfrm>
+          <a:prstGeom prst="rect">
+            <a:avLst/>
+          </a:prstGeom>
+          <a:noFill/>
+          <a:ln/>
+        </p:spPr>
+        <p:txBody>
+          <a:bodyPr wrap="square" lIns="0" tIns="0" rIns="0" bIns="0" rtlCol="0" anchor="ctr"/>
+          <a:lstStyle/>
+          <a:p>
+            <a:pPr indent="0" marL="0">
+              <a:buNone/>
+            </a:pPr>
+            <a:r>
+              <a:rPr lang="en-US" sz="1300" dirty="0">
                 <a:solidFill>
                   <a:srgbClr val="0E1F0C"/>
                 </a:solidFill>
@@ -1744,128 +2076,220 @@
                 <a:ea typeface="Poppins" pitchFamily="34" charset="-122"/>
                 <a:cs typeface="Poppins" pitchFamily="34" charset="-120"/>
               </a:rPr>
-              <a:t>Lenas Feed</a:t>
-            </a:r>
-            <a:endParaRPr lang="en-US" sz="2000" dirty="0"/>
-          </a:p>
-        </p:txBody>
-      </p:sp>
-      <p:sp>
-        <p:nvSpPr>
-          <p:cNvPr id="15" name="Shape 12"/>
-          <p:cNvSpPr/>
-          <p:nvPr/>
-        </p:nvSpPr>
-        <p:spPr>
-          <a:xfrm>
-            <a:off x="5202022" y="685800"/>
-            <a:ext cx="1787652" cy="4942332"/>
+              <a:t>Jonas’ Feed</a:t>
+            </a:r>
+            <a:endParaRPr lang="en-US" sz="1300" dirty="0"/>
+          </a:p>
+        </p:txBody>
+      </p:sp>
+      <p:sp>
+        <p:nvSpPr>
+          <p:cNvPr id="25" name="Text 22"/>
+          <p:cNvSpPr txBox="1"/>
+          <p:nvPr/>
+        </p:nvSpPr>
+        <p:spPr>
+          <a:xfrm>
+            <a:off x="4587088" y="2606040"/>
+            <a:ext cx="3017520" cy="457200"/>
+          </a:xfrm>
+          <a:prstGeom prst="rect">
+            <a:avLst/>
+          </a:prstGeom>
+          <a:noFill/>
+          <a:ln/>
+        </p:spPr>
+        <p:txBody>
+          <a:bodyPr wrap="square" lIns="0" tIns="0" rIns="0" bIns="0" rtlCol="0" anchor="t"/>
+          <a:lstStyle/>
+          <a:p>
+            <a:pPr indent="0" marL="0">
+              <a:buNone/>
+            </a:pPr>
+            <a:r>
+              <a:rPr lang="en-US" sz="2200" b="1" dirty="0">
+                <a:solidFill>
+                  <a:srgbClr val="0E1F0C"/>
+                </a:solidFill>
+                <a:latin typeface="Poppins" pitchFamily="34" charset="0"/>
+                <a:ea typeface="Poppins" pitchFamily="34" charset="-122"/>
+                <a:cs typeface="Poppins" pitchFamily="34" charset="-120"/>
+              </a:rPr>
+              <a:t>Jonas’ Feed</a:t>
+            </a:r>
+            <a:endParaRPr lang="en-US" sz="2200" dirty="0"/>
+          </a:p>
+        </p:txBody>
+      </p:sp>
+      <p:sp>
+        <p:nvSpPr>
+          <p:cNvPr id="26" name="Shape 23"/>
+          <p:cNvSpPr/>
+          <p:nvPr/>
+        </p:nvSpPr>
+        <p:spPr>
+          <a:xfrm>
+            <a:off x="4587088" y="3200400"/>
+            <a:ext cx="1280160" cy="457200"/>
           </a:xfrm>
           <a:prstGeom prst="roundRect">
             <a:avLst>
-              <a:gd name="adj" fmla="val 15345"/>
+              <a:gd name="adj" fmla="val 16000"/>
             </a:avLst>
           </a:prstGeom>
           <a:solidFill>
-            <a:srgbClr val="12301A"/>
+            <a:srgbClr val="B1FF37"/>
           </a:solidFill>
           <a:ln w="12700">
             <a:solidFill>
-              <a:srgbClr val="12301A"/>
-            </a:solidFill>
-            <a:prstDash val="solid"/>
-          </a:ln>
-        </p:spPr>
-      </p:sp>
-      <p:sp>
-        <p:nvSpPr>
-          <p:cNvPr id="16" name="Shape 13"/>
-          <p:cNvSpPr/>
-          <p:nvPr/>
-        </p:nvSpPr>
-        <p:spPr>
-          <a:xfrm>
-            <a:off x="5293462" y="777240"/>
-            <a:ext cx="1604772" cy="4759452"/>
+              <a:srgbClr val="B1FF37"/>
+            </a:solidFill>
+            <a:prstDash val="solid"/>
+          </a:ln>
+        </p:spPr>
+      </p:sp>
+      <p:sp>
+        <p:nvSpPr>
+          <p:cNvPr id="27" name="Text 24"/>
+          <p:cNvSpPr txBox="1"/>
+          <p:nvPr/>
+        </p:nvSpPr>
+        <p:spPr>
+          <a:xfrm>
+            <a:off x="4587088" y="3200400"/>
+            <a:ext cx="1280160" cy="457200"/>
+          </a:xfrm>
+          <a:prstGeom prst="rect">
+            <a:avLst/>
+          </a:prstGeom>
+          <a:noFill/>
+          <a:ln/>
+        </p:spPr>
+        <p:txBody>
+          <a:bodyPr wrap="square" lIns="0" tIns="0" rIns="0" bIns="0" rtlCol="0" anchor="ctr"/>
+          <a:lstStyle/>
+          <a:p>
+            <a:pPr algn="ctr" indent="0" marL="0">
+              <a:buNone/>
+            </a:pPr>
+            <a:r>
+              <a:rPr lang="en-US" sz="1400" b="1" dirty="0">
+                <a:solidFill>
+                  <a:srgbClr val="0E1F0C"/>
+                </a:solidFill>
+                <a:latin typeface="Poppins" pitchFamily="34" charset="0"/>
+                <a:ea typeface="Poppins" pitchFamily="34" charset="-122"/>
+                <a:cs typeface="Poppins" pitchFamily="34" charset="-120"/>
+              </a:rPr>
+              <a:t>Fußball</a:t>
+            </a:r>
+            <a:endParaRPr lang="en-US" sz="1400" dirty="0"/>
+          </a:p>
+        </p:txBody>
+      </p:sp>
+      <p:sp>
+        <p:nvSpPr>
+          <p:cNvPr id="28" name="Shape 25"/>
+          <p:cNvSpPr/>
+          <p:nvPr/>
+        </p:nvSpPr>
+        <p:spPr>
+          <a:xfrm>
+            <a:off x="6004408" y="3200400"/>
+            <a:ext cx="914400" cy="457200"/>
           </a:xfrm>
           <a:prstGeom prst="roundRect">
             <a:avLst>
-              <a:gd name="adj" fmla="val 12536"/>
+              <a:gd name="adj" fmla="val 16000"/>
             </a:avLst>
           </a:prstGeom>
           <a:solidFill>
-            <a:srgbClr val="FBFFF4"/>
+            <a:srgbClr val="B1FF37"/>
           </a:solidFill>
           <a:ln w="12700">
             <a:solidFill>
-              <a:srgbClr val="FBFFF4"/>
-            </a:solidFill>
-            <a:prstDash val="solid"/>
-          </a:ln>
-        </p:spPr>
-      </p:sp>
-      <p:sp>
-        <p:nvSpPr>
-          <p:cNvPr id="17" name="Shape 14"/>
-          <p:cNvSpPr/>
-          <p:nvPr/>
-        </p:nvSpPr>
-        <p:spPr>
-          <a:xfrm>
-            <a:off x="5412334" y="1001268"/>
-            <a:ext cx="1367028" cy="1261872"/>
+              <a:srgbClr val="B1FF37"/>
+            </a:solidFill>
+            <a:prstDash val="solid"/>
+          </a:ln>
+        </p:spPr>
+      </p:sp>
+      <p:sp>
+        <p:nvSpPr>
+          <p:cNvPr id="29" name="Text 26"/>
+          <p:cNvSpPr txBox="1"/>
+          <p:nvPr/>
+        </p:nvSpPr>
+        <p:spPr>
+          <a:xfrm>
+            <a:off x="6004408" y="3200400"/>
+            <a:ext cx="914400" cy="457200"/>
+          </a:xfrm>
+          <a:prstGeom prst="rect">
+            <a:avLst/>
+          </a:prstGeom>
+          <a:noFill/>
+          <a:ln/>
+        </p:spPr>
+        <p:txBody>
+          <a:bodyPr wrap="square" lIns="0" tIns="0" rIns="0" bIns="0" rtlCol="0" anchor="ctr"/>
+          <a:lstStyle/>
+          <a:p>
+            <a:pPr algn="ctr" indent="0" marL="0">
+              <a:buNone/>
+            </a:pPr>
+            <a:r>
+              <a:rPr lang="en-US" sz="1400" b="1" dirty="0">
+                <a:solidFill>
+                  <a:srgbClr val="0E1F0C"/>
+                </a:solidFill>
+                <a:latin typeface="Poppins" pitchFamily="34" charset="0"/>
+                <a:ea typeface="Poppins" pitchFamily="34" charset="-122"/>
+                <a:cs typeface="Poppins" pitchFamily="34" charset="-120"/>
+              </a:rPr>
+              <a:t>Tore</a:t>
+            </a:r>
+            <a:endParaRPr lang="en-US" sz="1400" dirty="0"/>
+          </a:p>
+        </p:txBody>
+      </p:sp>
+      <p:sp>
+        <p:nvSpPr>
+          <p:cNvPr id="30" name="Shape 27"/>
+          <p:cNvSpPr/>
+          <p:nvPr/>
+        </p:nvSpPr>
+        <p:spPr>
+          <a:xfrm>
+            <a:off x="4587088" y="3794760"/>
+            <a:ext cx="2011680" cy="457200"/>
           </a:xfrm>
           <a:prstGeom prst="roundRect">
             <a:avLst>
-              <a:gd name="adj" fmla="val 8696"/>
+              <a:gd name="adj" fmla="val 16000"/>
             </a:avLst>
           </a:prstGeom>
           <a:solidFill>
-            <a:srgbClr val="DDF3B8"/>
+            <a:srgbClr val="B1FF37"/>
           </a:solidFill>
           <a:ln w="12700">
             <a:solidFill>
-              <a:srgbClr val="DDF3B8"/>
-            </a:solidFill>
-            <a:prstDash val="solid"/>
-          </a:ln>
-        </p:spPr>
-      </p:sp>
-      <p:sp>
-        <p:nvSpPr>
-          <p:cNvPr id="18" name="Shape 15"/>
-          <p:cNvSpPr/>
-          <p:nvPr/>
-        </p:nvSpPr>
-        <p:spPr>
-          <a:xfrm>
-            <a:off x="5601614" y="1169518"/>
-            <a:ext cx="420624" cy="420624"/>
-          </a:xfrm>
-          <a:prstGeom prst="ellipse">
-            <a:avLst/>
-          </a:prstGeom>
-          <a:solidFill>
-            <a:srgbClr val="26720A"/>
-          </a:solidFill>
-          <a:ln w="12700">
-            <a:solidFill>
-              <a:srgbClr val="26720A"/>
-            </a:solidFill>
-            <a:prstDash val="solid"/>
-          </a:ln>
-        </p:spPr>
-      </p:sp>
-      <p:sp>
-        <p:nvSpPr>
-          <p:cNvPr id="19" name="Text 16"/>
+              <a:srgbClr val="B1FF37"/>
+            </a:solidFill>
+            <a:prstDash val="solid"/>
+          </a:ln>
+        </p:spPr>
+      </p:sp>
+      <p:sp>
+        <p:nvSpPr>
+          <p:cNvPr id="31" name="Text 28"/>
           <p:cNvSpPr txBox="1"/>
           <p:nvPr/>
         </p:nvSpPr>
         <p:spPr>
           <a:xfrm>
-            <a:off x="5538521" y="1653235"/>
-            <a:ext cx="1114654" cy="578358"/>
+            <a:off x="4587088" y="3794760"/>
+            <a:ext cx="2011680" cy="457200"/>
           </a:xfrm>
           <a:prstGeom prst="rect">
             <a:avLst/>
@@ -1877,7 +2301,7 @@
           <a:bodyPr wrap="square" lIns="0" tIns="0" rIns="0" bIns="0" rtlCol="0" anchor="ctr"/>
           <a:lstStyle/>
           <a:p>
-            <a:pPr indent="0" marL="0">
+            <a:pPr algn="ctr" indent="0" marL="0">
               <a:buNone/>
             </a:pPr>
             <a:r>
@@ -1897,21 +2321,112 @@
       </p:sp>
       <p:sp>
         <p:nvSpPr>
-          <p:cNvPr id="20" name="Shape 17"/>
-          <p:cNvSpPr/>
-          <p:nvPr/>
-        </p:nvSpPr>
-        <p:spPr>
-          <a:xfrm>
-            <a:off x="5412334" y="2473452"/>
-            <a:ext cx="1367028" cy="1261872"/>
+          <p:cNvPr id="32" name="Text 29"/>
+          <p:cNvSpPr txBox="1"/>
+          <p:nvPr/>
+        </p:nvSpPr>
+        <p:spPr>
+          <a:xfrm>
+            <a:off x="4587088" y="4754880"/>
+            <a:ext cx="3017520" cy="457200"/>
+          </a:xfrm>
+          <a:prstGeom prst="rect">
+            <a:avLst/>
+          </a:prstGeom>
+          <a:noFill/>
+          <a:ln/>
+        </p:spPr>
+        <p:txBody>
+          <a:bodyPr wrap="square" lIns="0" tIns="0" rIns="0" bIns="0" rtlCol="0" anchor="t"/>
+          <a:lstStyle/>
+          <a:p>
+            <a:pPr indent="0" marL="0">
+              <a:buNone/>
+            </a:pPr>
+            <a:r>
+              <a:rPr lang="en-US" sz="1400" dirty="0">
+                <a:solidFill>
+                  <a:srgbClr val="5B6B50"/>
+                </a:solidFill>
+                <a:latin typeface="Poppins" pitchFamily="34" charset="0"/>
+                <a:ea typeface="Poppins" pitchFamily="34" charset="-122"/>
+                <a:cs typeface="Poppins" pitchFamily="34" charset="-120"/>
+              </a:rPr>
+              <a:t>Fast nur Fußball.</a:t>
+            </a:r>
+            <a:endParaRPr lang="en-US" sz="1400" dirty="0"/>
+          </a:p>
+        </p:txBody>
+      </p:sp>
+      <p:sp>
+        <p:nvSpPr>
+          <p:cNvPr id="33" name="Shape 30"/>
+          <p:cNvSpPr/>
+          <p:nvPr/>
+        </p:nvSpPr>
+        <p:spPr>
+          <a:xfrm>
+            <a:off x="8198968" y="1508760"/>
+            <a:ext cx="3474720" cy="3840480"/>
           </a:xfrm>
           <a:prstGeom prst="roundRect">
             <a:avLst>
-              <a:gd name="adj" fmla="val 8696"/>
+              <a:gd name="adj" fmla="val 3158"/>
             </a:avLst>
           </a:prstGeom>
           <a:solidFill>
+            <a:srgbClr val="FBFFF4"/>
+          </a:solidFill>
+          <a:ln w="15875">
+            <a:solidFill>
+              <a:srgbClr val="B8D98A"/>
+            </a:solidFill>
+            <a:prstDash val="solid"/>
+          </a:ln>
+        </p:spPr>
+      </p:sp>
+      <p:sp>
+        <p:nvSpPr>
+          <p:cNvPr id="34" name="Shape 31"/>
+          <p:cNvSpPr/>
+          <p:nvPr/>
+        </p:nvSpPr>
+        <p:spPr>
+          <a:xfrm>
+            <a:off x="8198968" y="1508760"/>
+            <a:ext cx="3474720" cy="822960"/>
+          </a:xfrm>
+          <a:prstGeom prst="roundRect">
+            <a:avLst>
+              <a:gd name="adj" fmla="val 13333"/>
+            </a:avLst>
+          </a:prstGeom>
+          <a:solidFill>
+            <a:srgbClr val="12301A"/>
+          </a:solidFill>
+          <a:ln w="12700">
+            <a:solidFill>
+              <a:srgbClr val="12301A"/>
+            </a:solidFill>
+            <a:prstDash val="solid"/>
+          </a:ln>
+        </p:spPr>
+      </p:sp>
+      <p:sp>
+        <p:nvSpPr>
+          <p:cNvPr id="35" name="Shape 32"/>
+          <p:cNvSpPr/>
+          <p:nvPr/>
+        </p:nvSpPr>
+        <p:spPr>
+          <a:xfrm>
+            <a:off x="8208112" y="1920240"/>
+            <a:ext cx="3456432" cy="457200"/>
+          </a:xfrm>
+          <a:prstGeom prst="rect">
+            <a:avLst/>
+          </a:prstGeom>
+          <a:solidFill>
             <a:srgbClr val="DDF3B8"/>
           </a:solidFill>
           <a:ln w="12700">
@@ -1924,39 +2439,14 @@
       </p:sp>
       <p:sp>
         <p:nvSpPr>
-          <p:cNvPr id="21" name="Shape 18"/>
-          <p:cNvSpPr/>
-          <p:nvPr/>
-        </p:nvSpPr>
-        <p:spPr>
-          <a:xfrm>
-            <a:off x="5601614" y="2641702"/>
-            <a:ext cx="420624" cy="420624"/>
-          </a:xfrm>
-          <a:prstGeom prst="ellipse">
-            <a:avLst/>
-          </a:prstGeom>
-          <a:solidFill>
-            <a:srgbClr val="26720A"/>
-          </a:solidFill>
-          <a:ln w="12700">
-            <a:solidFill>
-              <a:srgbClr val="26720A"/>
-            </a:solidFill>
-            <a:prstDash val="solid"/>
-          </a:ln>
-        </p:spPr>
-      </p:sp>
-      <p:sp>
-        <p:nvSpPr>
-          <p:cNvPr id="22" name="Text 19"/>
+          <p:cNvPr id="36" name="Text 33"/>
           <p:cNvSpPr txBox="1"/>
           <p:nvPr/>
         </p:nvSpPr>
         <p:spPr>
           <a:xfrm>
-            <a:off x="5538521" y="3125419"/>
-            <a:ext cx="1114654" cy="578358"/>
+            <a:off x="9479128" y="1563624"/>
+            <a:ext cx="2011680" cy="310896"/>
           </a:xfrm>
           <a:prstGeom prst="rect">
             <a:avLst/>
@@ -1968,7 +2458,205 @@
           <a:bodyPr wrap="square" lIns="0" tIns="0" rIns="0" bIns="0" rtlCol="0" anchor="ctr"/>
           <a:lstStyle/>
           <a:p>
+            <a:pPr algn="r" indent="0" marL="0">
+              <a:buNone/>
+            </a:pPr>
+            <a:r>
+              <a:rPr lang="en-US" sz="1300" dirty="0">
+                <a:solidFill>
+                  <a:srgbClr val="FBFFF4"/>
+                </a:solidFill>
+                <a:latin typeface="Poppins" pitchFamily="34" charset="0"/>
+                <a:ea typeface="Poppins" pitchFamily="34" charset="-122"/>
+                <a:cs typeface="Poppins" pitchFamily="34" charset="-120"/>
+              </a:rPr>
+              <a:t>Für dich</a:t>
+            </a:r>
+            <a:endParaRPr lang="en-US" sz="1300" dirty="0"/>
+          </a:p>
+        </p:txBody>
+      </p:sp>
+      <p:sp>
+        <p:nvSpPr>
+          <p:cNvPr id="37" name="Shape 34"/>
+          <p:cNvSpPr/>
+          <p:nvPr/>
+        </p:nvSpPr>
+        <p:spPr>
+          <a:xfrm>
+            <a:off x="8381848" y="1965960"/>
+            <a:ext cx="1920240" cy="411480"/>
+          </a:xfrm>
+          <a:prstGeom prst="roundRect">
+            <a:avLst>
+              <a:gd name="adj" fmla="val 17778"/>
+            </a:avLst>
+          </a:prstGeom>
+          <a:solidFill>
+            <a:srgbClr val="FBFFF4"/>
+          </a:solidFill>
+          <a:ln w="12700">
+            <a:solidFill>
+              <a:srgbClr val="FBFFF4"/>
+            </a:solidFill>
+            <a:prstDash val="solid"/>
+          </a:ln>
+        </p:spPr>
+      </p:sp>
+      <p:sp>
+        <p:nvSpPr>
+          <p:cNvPr id="38" name="Shape 35"/>
+          <p:cNvSpPr/>
+          <p:nvPr/>
+        </p:nvSpPr>
+        <p:spPr>
+          <a:xfrm>
+            <a:off x="8509864" y="2093976"/>
+            <a:ext cx="146304" cy="146304"/>
+          </a:xfrm>
+          <a:prstGeom prst="roundRect">
+            <a:avLst>
+              <a:gd name="adj" fmla="val 18750"/>
+            </a:avLst>
+          </a:prstGeom>
+          <a:solidFill>
+            <a:srgbClr val="DDF3B8"/>
+          </a:solidFill>
+          <a:ln w="6350">
+            <a:solidFill>
+              <a:srgbClr val="B8D98A"/>
+            </a:solidFill>
+            <a:prstDash val="solid"/>
+          </a:ln>
+        </p:spPr>
+      </p:sp>
+      <p:sp>
+        <p:nvSpPr>
+          <p:cNvPr id="39" name="Text 36"/>
+          <p:cNvSpPr txBox="1"/>
+          <p:nvPr/>
+        </p:nvSpPr>
+        <p:spPr>
+          <a:xfrm>
+            <a:off x="8747608" y="1965960"/>
+            <a:ext cx="1508760" cy="411480"/>
+          </a:xfrm>
+          <a:prstGeom prst="rect">
+            <a:avLst/>
+          </a:prstGeom>
+          <a:noFill/>
+          <a:ln/>
+        </p:spPr>
+        <p:txBody>
+          <a:bodyPr wrap="square" lIns="0" tIns="0" rIns="0" bIns="0" rtlCol="0" anchor="ctr"/>
+          <a:lstStyle/>
+          <a:p>
             <a:pPr indent="0" marL="0">
+              <a:buNone/>
+            </a:pPr>
+            <a:r>
+              <a:rPr lang="en-US" sz="1300" dirty="0">
+                <a:solidFill>
+                  <a:srgbClr val="0E1F0C"/>
+                </a:solidFill>
+                <a:latin typeface="Poppins" pitchFamily="34" charset="0"/>
+                <a:ea typeface="Poppins" pitchFamily="34" charset="-122"/>
+                <a:cs typeface="Poppins" pitchFamily="34" charset="-120"/>
+              </a:rPr>
+              <a:t>Dein Feed</a:t>
+            </a:r>
+            <a:endParaRPr lang="en-US" sz="1300" dirty="0"/>
+          </a:p>
+        </p:txBody>
+      </p:sp>
+      <p:sp>
+        <p:nvSpPr>
+          <p:cNvPr id="40" name="Text 37"/>
+          <p:cNvSpPr txBox="1"/>
+          <p:nvPr/>
+        </p:nvSpPr>
+        <p:spPr>
+          <a:xfrm>
+            <a:off x="8427568" y="2606040"/>
+            <a:ext cx="3017520" cy="457200"/>
+          </a:xfrm>
+          <a:prstGeom prst="rect">
+            <a:avLst/>
+          </a:prstGeom>
+          <a:noFill/>
+          <a:ln/>
+        </p:spPr>
+        <p:txBody>
+          <a:bodyPr wrap="square" lIns="0" tIns="0" rIns="0" bIns="0" rtlCol="0" anchor="t"/>
+          <a:lstStyle/>
+          <a:p>
+            <a:pPr indent="0" marL="0">
+              <a:buNone/>
+            </a:pPr>
+            <a:r>
+              <a:rPr lang="en-US" sz="2200" b="1" dirty="0">
+                <a:solidFill>
+                  <a:srgbClr val="0E1F0C"/>
+                </a:solidFill>
+                <a:latin typeface="Poppins" pitchFamily="34" charset="0"/>
+                <a:ea typeface="Poppins" pitchFamily="34" charset="-122"/>
+                <a:cs typeface="Poppins" pitchFamily="34" charset="-120"/>
+              </a:rPr>
+              <a:t>Dein Feed</a:t>
+            </a:r>
+            <a:endParaRPr lang="en-US" sz="2200" dirty="0"/>
+          </a:p>
+        </p:txBody>
+      </p:sp>
+      <p:sp>
+        <p:nvSpPr>
+          <p:cNvPr id="41" name="Shape 38"/>
+          <p:cNvSpPr/>
+          <p:nvPr/>
+        </p:nvSpPr>
+        <p:spPr>
+          <a:xfrm>
+            <a:off x="8427568" y="3200400"/>
+            <a:ext cx="1188720" cy="457200"/>
+          </a:xfrm>
+          <a:prstGeom prst="roundRect">
+            <a:avLst>
+              <a:gd name="adj" fmla="val 16000"/>
+            </a:avLst>
+          </a:prstGeom>
+          <a:solidFill>
+            <a:srgbClr val="B1FF37"/>
+          </a:solidFill>
+          <a:ln w="12700">
+            <a:solidFill>
+              <a:srgbClr val="B1FF37"/>
+            </a:solidFill>
+            <a:prstDash val="solid"/>
+          </a:ln>
+        </p:spPr>
+      </p:sp>
+      <p:sp>
+        <p:nvSpPr>
+          <p:cNvPr id="42" name="Text 39"/>
+          <p:cNvSpPr txBox="1"/>
+          <p:nvPr/>
+        </p:nvSpPr>
+        <p:spPr>
+          <a:xfrm>
+            <a:off x="8427568" y="3200400"/>
+            <a:ext cx="1188720" cy="457200"/>
+          </a:xfrm>
+          <a:prstGeom prst="rect">
+            <a:avLst/>
+          </a:prstGeom>
+          <a:noFill/>
+          <a:ln/>
+        </p:spPr>
+        <p:txBody>
+          <a:bodyPr wrap="square" lIns="0" tIns="0" rIns="0" bIns="0" rtlCol="0" anchor="ctr"/>
+          <a:lstStyle/>
+          <a:p>
+            <a:pPr algn="ctr" indent="0" marL="0">
               <a:buNone/>
             </a:pPr>
             <a:r>
@@ -1980,7 +2668,7 @@
                 <a:ea typeface="Poppins" pitchFamily="34" charset="-122"/>
                 <a:cs typeface="Poppins" pitchFamily="34" charset="-120"/>
               </a:rPr>
-              <a:t>Tor des Monats</a:t>
+              <a:t>Katzen</a:t>
             </a:r>
             <a:endParaRPr lang="en-US" sz="1400" dirty="0"/>
           </a:p>
@@ -1988,66 +2676,41 @@
       </p:sp>
       <p:sp>
         <p:nvSpPr>
-          <p:cNvPr id="23" name="Shape 20"/>
-          <p:cNvSpPr/>
-          <p:nvPr/>
-        </p:nvSpPr>
-        <p:spPr>
-          <a:xfrm>
-            <a:off x="5412334" y="3945636"/>
-            <a:ext cx="1367028" cy="1261872"/>
+          <p:cNvPr id="43" name="Shape 40"/>
+          <p:cNvSpPr/>
+          <p:nvPr/>
+        </p:nvSpPr>
+        <p:spPr>
+          <a:xfrm>
+            <a:off x="9753448" y="3200400"/>
+            <a:ext cx="1645920" cy="457200"/>
           </a:xfrm>
           <a:prstGeom prst="roundRect">
             <a:avLst>
-              <a:gd name="adj" fmla="val 8696"/>
+              <a:gd name="adj" fmla="val 16000"/>
             </a:avLst>
           </a:prstGeom>
           <a:solidFill>
-            <a:srgbClr val="DDF3B8"/>
+            <a:srgbClr val="B1FF37"/>
           </a:solidFill>
           <a:ln w="12700">
             <a:solidFill>
-              <a:srgbClr val="DDF3B8"/>
-            </a:solidFill>
-            <a:prstDash val="solid"/>
-          </a:ln>
-        </p:spPr>
-      </p:sp>
-      <p:sp>
-        <p:nvSpPr>
-          <p:cNvPr id="24" name="Shape 21"/>
-          <p:cNvSpPr/>
-          <p:nvPr/>
-        </p:nvSpPr>
-        <p:spPr>
-          <a:xfrm>
-            <a:off x="5601614" y="4113886"/>
-            <a:ext cx="420624" cy="420624"/>
-          </a:xfrm>
-          <a:prstGeom prst="ellipse">
-            <a:avLst/>
-          </a:prstGeom>
-          <a:solidFill>
-            <a:srgbClr val="26720A"/>
-          </a:solidFill>
-          <a:ln w="12700">
-            <a:solidFill>
-              <a:srgbClr val="26720A"/>
-            </a:solidFill>
-            <a:prstDash val="solid"/>
-          </a:ln>
-        </p:spPr>
-      </p:sp>
-      <p:sp>
-        <p:nvSpPr>
-          <p:cNvPr id="25" name="Text 22"/>
+              <a:srgbClr val="B1FF37"/>
+            </a:solidFill>
+            <a:prstDash val="solid"/>
+          </a:ln>
+        </p:spPr>
+      </p:sp>
+      <p:sp>
+        <p:nvSpPr>
+          <p:cNvPr id="44" name="Text 41"/>
           <p:cNvSpPr txBox="1"/>
           <p:nvPr/>
         </p:nvSpPr>
         <p:spPr>
           <a:xfrm>
-            <a:off x="5538521" y="4597603"/>
-            <a:ext cx="1114654" cy="578358"/>
+            <a:off x="9753448" y="3200400"/>
+            <a:ext cx="1645920" cy="457200"/>
           </a:xfrm>
           <a:prstGeom prst="rect">
             <a:avLst/>
@@ -2059,7 +2722,7 @@
           <a:bodyPr wrap="square" lIns="0" tIns="0" rIns="0" bIns="0" rtlCol="0" anchor="ctr"/>
           <a:lstStyle/>
           <a:p>
-            <a:pPr indent="0" marL="0">
+            <a:pPr algn="ctr" indent="0" marL="0">
               <a:buNone/>
             </a:pPr>
             <a:r>
@@ -2071,7 +2734,7 @@
                 <a:ea typeface="Poppins" pitchFamily="34" charset="-122"/>
                 <a:cs typeface="Poppins" pitchFamily="34" charset="-120"/>
               </a:rPr>
-              <a:t>Highlights</a:t>
+              <a:t>Minecraft</a:t>
             </a:r>
             <a:endParaRPr lang="en-US" sz="1400" dirty="0"/>
           </a:p>
@@ -2079,14 +2742,41 @@
       </p:sp>
       <p:sp>
         <p:nvSpPr>
-          <p:cNvPr id="26" name="Text 23"/>
+          <p:cNvPr id="45" name="Shape 42"/>
+          <p:cNvSpPr/>
+          <p:nvPr/>
+        </p:nvSpPr>
+        <p:spPr>
+          <a:xfrm>
+            <a:off x="8427568" y="3794760"/>
+            <a:ext cx="1920240" cy="457200"/>
+          </a:xfrm>
+          <a:prstGeom prst="roundRect">
+            <a:avLst>
+              <a:gd name="adj" fmla="val 16000"/>
+            </a:avLst>
+          </a:prstGeom>
+          <a:solidFill>
+            <a:srgbClr val="B1FF37"/>
+          </a:solidFill>
+          <a:ln w="12700">
+            <a:solidFill>
+              <a:srgbClr val="B1FF37"/>
+            </a:solidFill>
+            <a:prstDash val="solid"/>
+          </a:ln>
+        </p:spPr>
+      </p:sp>
+      <p:sp>
+        <p:nvSpPr>
+          <p:cNvPr id="46" name="Text 43"/>
           <p:cNvSpPr txBox="1"/>
           <p:nvPr/>
         </p:nvSpPr>
         <p:spPr>
           <a:xfrm>
-            <a:off x="5019142" y="5811012"/>
-            <a:ext cx="2153412" cy="411480"/>
+            <a:off x="8427568" y="3794760"/>
+            <a:ext cx="1920240" cy="457200"/>
           </a:xfrm>
           <a:prstGeom prst="rect">
             <a:avLst/>
@@ -2095,169 +2785,10 @@
           <a:ln/>
         </p:spPr>
         <p:txBody>
-          <a:bodyPr wrap="square" lIns="0" tIns="0" rIns="0" bIns="0" rtlCol="0" anchor="t"/>
+          <a:bodyPr wrap="square" lIns="0" tIns="0" rIns="0" bIns="0" rtlCol="0" anchor="ctr"/>
           <a:lstStyle/>
           <a:p>
             <a:pPr algn="ctr" indent="0" marL="0">
-              <a:buNone/>
-            </a:pPr>
-            <a:r>
-              <a:rPr lang="en-US" sz="2000" b="1" dirty="0">
-                <a:solidFill>
-                  <a:srgbClr val="0E1F0C"/>
-                </a:solidFill>
-                <a:latin typeface="Poppins" pitchFamily="34" charset="0"/>
-                <a:ea typeface="Poppins" pitchFamily="34" charset="-122"/>
-                <a:cs typeface="Poppins" pitchFamily="34" charset="-120"/>
-              </a:rPr>
-              <a:t>Jonas’ Feed</a:t>
-            </a:r>
-            <a:endParaRPr lang="en-US" sz="2000" dirty="0"/>
-          </a:p>
-        </p:txBody>
-      </p:sp>
-      <p:sp>
-        <p:nvSpPr>
-          <p:cNvPr id="27" name="Shape 24"/>
-          <p:cNvSpPr/>
-          <p:nvPr/>
-        </p:nvSpPr>
-        <p:spPr>
-          <a:xfrm>
-            <a:off x="7812634" y="685800"/>
-            <a:ext cx="1787652" cy="4942332"/>
-          </a:xfrm>
-          <a:prstGeom prst="roundRect">
-            <a:avLst>
-              <a:gd name="adj" fmla="val 15345"/>
-            </a:avLst>
-          </a:prstGeom>
-          <a:solidFill>
-            <a:srgbClr val="12301A"/>
-          </a:solidFill>
-          <a:ln w="12700">
-            <a:solidFill>
-              <a:srgbClr val="12301A"/>
-            </a:solidFill>
-            <a:prstDash val="solid"/>
-          </a:ln>
-        </p:spPr>
-      </p:sp>
-      <p:sp>
-        <p:nvSpPr>
-          <p:cNvPr id="28" name="Shape 25"/>
-          <p:cNvSpPr/>
-          <p:nvPr/>
-        </p:nvSpPr>
-        <p:spPr>
-          <a:xfrm>
-            <a:off x="7904074" y="777240"/>
-            <a:ext cx="1604772" cy="4759452"/>
-          </a:xfrm>
-          <a:prstGeom prst="roundRect">
-            <a:avLst>
-              <a:gd name="adj" fmla="val 12536"/>
-            </a:avLst>
-          </a:prstGeom>
-          <a:solidFill>
-            <a:srgbClr val="FBFFF4"/>
-          </a:solidFill>
-          <a:ln w="12700">
-            <a:solidFill>
-              <a:srgbClr val="FBFFF4"/>
-            </a:solidFill>
-            <a:prstDash val="solid"/>
-          </a:ln>
-        </p:spPr>
-      </p:sp>
-      <p:sp>
-        <p:nvSpPr>
-          <p:cNvPr id="29" name="Shape 26"/>
-          <p:cNvSpPr/>
-          <p:nvPr/>
-        </p:nvSpPr>
-        <p:spPr>
-          <a:xfrm>
-            <a:off x="8022946" y="1001268"/>
-            <a:ext cx="1367028" cy="1261872"/>
-          </a:xfrm>
-          <a:prstGeom prst="roundRect">
-            <a:avLst>
-              <a:gd name="adj" fmla="val 8696"/>
-            </a:avLst>
-          </a:prstGeom>
-          <a:solidFill>
-            <a:srgbClr val="B1FF37"/>
-          </a:solidFill>
-          <a:ln w="12700">
-            <a:solidFill>
-              <a:srgbClr val="B1FF37"/>
-            </a:solidFill>
-            <a:prstDash val="solid"/>
-          </a:ln>
-        </p:spPr>
-      </p:sp>
-      <p:sp>
-        <p:nvSpPr>
-          <p:cNvPr id="30" name="Text 27"/>
-          <p:cNvSpPr txBox="1"/>
-          <p:nvPr/>
-        </p:nvSpPr>
-        <p:spPr>
-          <a:xfrm>
-            <a:off x="8159648" y="1053846"/>
-            <a:ext cx="548640" cy="548640"/>
-          </a:xfrm>
-          <a:prstGeom prst="rect">
-            <a:avLst/>
-          </a:prstGeom>
-          <a:noFill/>
-          <a:ln/>
-        </p:spPr>
-        <p:txBody>
-          <a:bodyPr wrap="square" lIns="0" tIns="0" rIns="0" bIns="0" rtlCol="0" anchor="t"/>
-          <a:lstStyle/>
-          <a:p>
-            <a:pPr indent="0" marL="0">
-              <a:buNone/>
-            </a:pPr>
-            <a:r>
-              <a:rPr lang="en-US" sz="2600" b="1" dirty="0">
-                <a:solidFill>
-                  <a:srgbClr val="12301A"/>
-                </a:solidFill>
-                <a:latin typeface="Poppins" pitchFamily="34" charset="0"/>
-                <a:ea typeface="Poppins" pitchFamily="34" charset="-122"/>
-                <a:cs typeface="Poppins" pitchFamily="34" charset="-120"/>
-              </a:rPr>
-              <a:t>?</a:t>
-            </a:r>
-            <a:endParaRPr lang="en-US" sz="2600" dirty="0"/>
-          </a:p>
-        </p:txBody>
-      </p:sp>
-      <p:sp>
-        <p:nvSpPr>
-          <p:cNvPr id="31" name="Text 28"/>
-          <p:cNvSpPr txBox="1"/>
-          <p:nvPr/>
-        </p:nvSpPr>
-        <p:spPr>
-          <a:xfrm>
-            <a:off x="8149133" y="1653235"/>
-            <a:ext cx="1114654" cy="578358"/>
-          </a:xfrm>
-          <a:prstGeom prst="rect">
-            <a:avLst/>
-          </a:prstGeom>
-          <a:noFill/>
-          <a:ln/>
-        </p:spPr>
-        <p:txBody>
-          <a:bodyPr wrap="square" lIns="0" tIns="0" rIns="0" bIns="0" rtlCol="0" anchor="ctr"/>
-          <a:lstStyle/>
-          <a:p>
-            <a:pPr indent="0" marL="0">
               <a:buNone/>
             </a:pPr>
             <a:r>
@@ -2269,7 +2800,7 @@
                 <a:ea typeface="Poppins" pitchFamily="34" charset="-122"/>
                 <a:cs typeface="Poppins" pitchFamily="34" charset="-120"/>
               </a:rPr>
-              <a:t>Katzen?</a:t>
+              <a:t>Kochrezepte</a:t>
             </a:r>
             <a:endParaRPr lang="en-US" sz="1400" dirty="0"/>
           </a:p>
@@ -2277,41 +2808,14 @@
       </p:sp>
       <p:sp>
         <p:nvSpPr>
-          <p:cNvPr id="32" name="Shape 29"/>
-          <p:cNvSpPr/>
-          <p:nvPr/>
-        </p:nvSpPr>
-        <p:spPr>
-          <a:xfrm>
-            <a:off x="8022946" y="2473452"/>
-            <a:ext cx="1367028" cy="1261872"/>
-          </a:xfrm>
-          <a:prstGeom prst="roundRect">
-            <a:avLst>
-              <a:gd name="adj" fmla="val 8696"/>
-            </a:avLst>
-          </a:prstGeom>
-          <a:solidFill>
-            <a:srgbClr val="B1FF37"/>
-          </a:solidFill>
-          <a:ln w="12700">
-            <a:solidFill>
-              <a:srgbClr val="B1FF37"/>
-            </a:solidFill>
-            <a:prstDash val="solid"/>
-          </a:ln>
-        </p:spPr>
-      </p:sp>
-      <p:sp>
-        <p:nvSpPr>
-          <p:cNvPr id="33" name="Text 30"/>
+          <p:cNvPr id="47" name="Text 44"/>
           <p:cNvSpPr txBox="1"/>
           <p:nvPr/>
         </p:nvSpPr>
         <p:spPr>
           <a:xfrm>
-            <a:off x="8159648" y="2526030"/>
-            <a:ext cx="548640" cy="548640"/>
+            <a:off x="8427568" y="4754880"/>
+            <a:ext cx="3017520" cy="457200"/>
           </a:xfrm>
           <a:prstGeom prst="rect">
             <a:avLst/>
@@ -2327,200 +2831,17 @@
               <a:buNone/>
             </a:pPr>
             <a:r>
-              <a:rPr lang="en-US" sz="2600" b="1" dirty="0">
+              <a:rPr lang="en-US" sz="1400" dirty="0">
                 <a:solidFill>
-                  <a:srgbClr val="12301A"/>
+                  <a:srgbClr val="5B6B50"/>
                 </a:solidFill>
                 <a:latin typeface="Poppins" pitchFamily="34" charset="0"/>
                 <a:ea typeface="Poppins" pitchFamily="34" charset="-122"/>
                 <a:cs typeface="Poppins" pitchFamily="34" charset="-120"/>
               </a:rPr>
-              <a:t>?</a:t>
-            </a:r>
-            <a:endParaRPr lang="en-US" sz="2600" dirty="0"/>
-          </a:p>
-        </p:txBody>
-      </p:sp>
-      <p:sp>
-        <p:nvSpPr>
-          <p:cNvPr id="34" name="Text 31"/>
-          <p:cNvSpPr txBox="1"/>
-          <p:nvPr/>
-        </p:nvSpPr>
-        <p:spPr>
-          <a:xfrm>
-            <a:off x="8149133" y="3125419"/>
-            <a:ext cx="1114654" cy="578358"/>
-          </a:xfrm>
-          <a:prstGeom prst="rect">
-            <a:avLst/>
-          </a:prstGeom>
-          <a:noFill/>
-          <a:ln/>
-        </p:spPr>
-        <p:txBody>
-          <a:bodyPr wrap="square" lIns="0" tIns="0" rIns="0" bIns="0" rtlCol="0" anchor="ctr"/>
-          <a:lstStyle/>
-          <a:p>
-            <a:pPr indent="0" marL="0">
-              <a:buNone/>
-            </a:pPr>
-            <a:r>
-              <a:rPr lang="en-US" sz="1400" b="1" dirty="0">
-                <a:solidFill>
-                  <a:srgbClr val="0E1F0C"/>
-                </a:solidFill>
-                <a:latin typeface="Poppins" pitchFamily="34" charset="0"/>
-                <a:ea typeface="Poppins" pitchFamily="34" charset="-122"/>
-                <a:cs typeface="Poppins" pitchFamily="34" charset="-120"/>
-              </a:rPr>
-              <a:t>Minecraft?</a:t>
+              <a:t>Was zeigt dir die App – und warum?</a:t>
             </a:r>
             <a:endParaRPr lang="en-US" sz="1400" dirty="0"/>
-          </a:p>
-        </p:txBody>
-      </p:sp>
-      <p:sp>
-        <p:nvSpPr>
-          <p:cNvPr id="35" name="Shape 32"/>
-          <p:cNvSpPr/>
-          <p:nvPr/>
-        </p:nvSpPr>
-        <p:spPr>
-          <a:xfrm>
-            <a:off x="8022946" y="3945636"/>
-            <a:ext cx="1367028" cy="1261872"/>
-          </a:xfrm>
-          <a:prstGeom prst="roundRect">
-            <a:avLst>
-              <a:gd name="adj" fmla="val 8696"/>
-            </a:avLst>
-          </a:prstGeom>
-          <a:solidFill>
-            <a:srgbClr val="B1FF37"/>
-          </a:solidFill>
-          <a:ln w="12700">
-            <a:solidFill>
-              <a:srgbClr val="B1FF37"/>
-            </a:solidFill>
-            <a:prstDash val="solid"/>
-          </a:ln>
-        </p:spPr>
-      </p:sp>
-      <p:sp>
-        <p:nvSpPr>
-          <p:cNvPr id="36" name="Text 33"/>
-          <p:cNvSpPr txBox="1"/>
-          <p:nvPr/>
-        </p:nvSpPr>
-        <p:spPr>
-          <a:xfrm>
-            <a:off x="8159648" y="3998214"/>
-            <a:ext cx="548640" cy="548640"/>
-          </a:xfrm>
-          <a:prstGeom prst="rect">
-            <a:avLst/>
-          </a:prstGeom>
-          <a:noFill/>
-          <a:ln/>
-        </p:spPr>
-        <p:txBody>
-          <a:bodyPr wrap="square" lIns="0" tIns="0" rIns="0" bIns="0" rtlCol="0" anchor="t"/>
-          <a:lstStyle/>
-          <a:p>
-            <a:pPr indent="0" marL="0">
-              <a:buNone/>
-            </a:pPr>
-            <a:r>
-              <a:rPr lang="en-US" sz="2600" b="1" dirty="0">
-                <a:solidFill>
-                  <a:srgbClr val="12301A"/>
-                </a:solidFill>
-                <a:latin typeface="Poppins" pitchFamily="34" charset="0"/>
-                <a:ea typeface="Poppins" pitchFamily="34" charset="-122"/>
-                <a:cs typeface="Poppins" pitchFamily="34" charset="-120"/>
-              </a:rPr>
-              <a:t>?</a:t>
-            </a:r>
-            <a:endParaRPr lang="en-US" sz="2600" dirty="0"/>
-          </a:p>
-        </p:txBody>
-      </p:sp>
-      <p:sp>
-        <p:nvSpPr>
-          <p:cNvPr id="37" name="Text 34"/>
-          <p:cNvSpPr txBox="1"/>
-          <p:nvPr/>
-        </p:nvSpPr>
-        <p:spPr>
-          <a:xfrm>
-            <a:off x="8149133" y="4597603"/>
-            <a:ext cx="1114654" cy="578358"/>
-          </a:xfrm>
-          <a:prstGeom prst="rect">
-            <a:avLst/>
-          </a:prstGeom>
-          <a:noFill/>
-          <a:ln/>
-        </p:spPr>
-        <p:txBody>
-          <a:bodyPr wrap="square" lIns="0" tIns="0" rIns="0" bIns="0" rtlCol="0" anchor="ctr"/>
-          <a:lstStyle/>
-          <a:p>
-            <a:pPr indent="0" marL="0">
-              <a:buNone/>
-            </a:pPr>
-            <a:r>
-              <a:rPr lang="en-US" sz="1400" b="1" dirty="0">
-                <a:solidFill>
-                  <a:srgbClr val="0E1F0C"/>
-                </a:solidFill>
-                <a:latin typeface="Poppins" pitchFamily="34" charset="0"/>
-                <a:ea typeface="Poppins" pitchFamily="34" charset="-122"/>
-                <a:cs typeface="Poppins" pitchFamily="34" charset="-120"/>
-              </a:rPr>
-              <a:t>Kochen?</a:t>
-            </a:r>
-            <a:endParaRPr lang="en-US" sz="1400" dirty="0"/>
-          </a:p>
-        </p:txBody>
-      </p:sp>
-      <p:sp>
-        <p:nvSpPr>
-          <p:cNvPr id="38" name="Text 35"/>
-          <p:cNvSpPr txBox="1"/>
-          <p:nvPr/>
-        </p:nvSpPr>
-        <p:spPr>
-          <a:xfrm>
-            <a:off x="7629754" y="5811012"/>
-            <a:ext cx="2153412" cy="411480"/>
-          </a:xfrm>
-          <a:prstGeom prst="rect">
-            <a:avLst/>
-          </a:prstGeom>
-          <a:noFill/>
-          <a:ln/>
-        </p:spPr>
-        <p:txBody>
-          <a:bodyPr wrap="square" lIns="0" tIns="0" rIns="0" bIns="0" rtlCol="0" anchor="t"/>
-          <a:lstStyle/>
-          <a:p>
-            <a:pPr algn="ctr" indent="0" marL="0">
-              <a:buNone/>
-            </a:pPr>
-            <a:r>
-              <a:rPr lang="en-US" sz="2000" b="1" dirty="0">
-                <a:solidFill>
-                  <a:srgbClr val="26720A"/>
-                </a:solidFill>
-                <a:latin typeface="Poppins" pitchFamily="34" charset="0"/>
-                <a:ea typeface="Poppins" pitchFamily="34" charset="-122"/>
-                <a:cs typeface="Poppins" pitchFamily="34" charset="-120"/>
-              </a:rPr>
-              <a:t>Dein Feed</a:t>
-            </a:r>
-            <a:endParaRPr lang="en-US" sz="2000" dirty="0"/>
           </a:p>
         </p:txBody>
       </p:sp>
@@ -2557,20 +2878,20 @@
         </p:nvSpPr>
         <p:spPr>
           <a:xfrm>
-            <a:off x="2591410" y="685800"/>
-            <a:ext cx="1787652" cy="4942332"/>
+            <a:off x="518008" y="1508760"/>
+            <a:ext cx="3474720" cy="3840480"/>
           </a:xfrm>
           <a:prstGeom prst="roundRect">
             <a:avLst>
-              <a:gd name="adj" fmla="val 15345"/>
+              <a:gd name="adj" fmla="val 3158"/>
             </a:avLst>
           </a:prstGeom>
           <a:solidFill>
-            <a:srgbClr val="12301A"/>
-          </a:solidFill>
-          <a:ln w="12700">
-            <a:solidFill>
-              <a:srgbClr val="12301A"/>
+            <a:srgbClr val="FBFFF4"/>
+          </a:solidFill>
+          <a:ln w="15875">
+            <a:solidFill>
+              <a:srgbClr val="B8D98A"/>
             </a:solidFill>
             <a:prstDash val="solid"/>
           </a:ln>
@@ -2584,20 +2905,20 @@
         </p:nvSpPr>
         <p:spPr>
           <a:xfrm>
-            <a:off x="2682850" y="777240"/>
-            <a:ext cx="1604772" cy="4759452"/>
+            <a:off x="518008" y="1508760"/>
+            <a:ext cx="3474720" cy="822960"/>
           </a:xfrm>
           <a:prstGeom prst="roundRect">
             <a:avLst>
-              <a:gd name="adj" fmla="val 12536"/>
+              <a:gd name="adj" fmla="val 13333"/>
             </a:avLst>
           </a:prstGeom>
           <a:solidFill>
-            <a:srgbClr val="FBFFF4"/>
+            <a:srgbClr val="12301A"/>
           </a:solidFill>
           <a:ln w="12700">
             <a:solidFill>
-              <a:srgbClr val="FBFFF4"/>
+              <a:srgbClr val="12301A"/>
             </a:solidFill>
             <a:prstDash val="solid"/>
           </a:ln>
@@ -2611,60 +2932,126 @@
         </p:nvSpPr>
         <p:spPr>
           <a:xfrm>
-            <a:off x="2801722" y="1001268"/>
-            <a:ext cx="1367028" cy="1261872"/>
+            <a:off x="527152" y="1920240"/>
+            <a:ext cx="3456432" cy="457200"/>
+          </a:xfrm>
+          <a:prstGeom prst="rect">
+            <a:avLst/>
+          </a:prstGeom>
+          <a:solidFill>
+            <a:srgbClr val="DDF3B8"/>
+          </a:solidFill>
+          <a:ln w="12700">
+            <a:solidFill>
+              <a:srgbClr val="DDF3B8"/>
+            </a:solidFill>
+            <a:prstDash val="solid"/>
+          </a:ln>
+        </p:spPr>
+      </p:sp>
+      <p:sp>
+        <p:nvSpPr>
+          <p:cNvPr id="6" name="Text 3"/>
+          <p:cNvSpPr txBox="1"/>
+          <p:nvPr/>
+        </p:nvSpPr>
+        <p:spPr>
+          <a:xfrm>
+            <a:off x="1798168" y="1563624"/>
+            <a:ext cx="2011680" cy="310896"/>
+          </a:xfrm>
+          <a:prstGeom prst="rect">
+            <a:avLst/>
+          </a:prstGeom>
+          <a:noFill/>
+          <a:ln/>
+        </p:spPr>
+        <p:txBody>
+          <a:bodyPr wrap="square" lIns="0" tIns="0" rIns="0" bIns="0" rtlCol="0" anchor="ctr"/>
+          <a:lstStyle/>
+          <a:p>
+            <a:pPr algn="r" indent="0" marL="0">
+              <a:buNone/>
+            </a:pPr>
+            <a:r>
+              <a:rPr lang="en-US" sz="1300" dirty="0">
+                <a:solidFill>
+                  <a:srgbClr val="FBFFF4"/>
+                </a:solidFill>
+                <a:latin typeface="Poppins" pitchFamily="34" charset="0"/>
+                <a:ea typeface="Poppins" pitchFamily="34" charset="-122"/>
+                <a:cs typeface="Poppins" pitchFamily="34" charset="-120"/>
+              </a:rPr>
+              <a:t>Für dich</a:t>
+            </a:r>
+            <a:endParaRPr lang="en-US" sz="1300" dirty="0"/>
+          </a:p>
+        </p:txBody>
+      </p:sp>
+      <p:sp>
+        <p:nvSpPr>
+          <p:cNvPr id="7" name="Shape 4"/>
+          <p:cNvSpPr/>
+          <p:nvPr/>
+        </p:nvSpPr>
+        <p:spPr>
+          <a:xfrm>
+            <a:off x="700888" y="1965960"/>
+            <a:ext cx="1920240" cy="411480"/>
           </a:xfrm>
           <a:prstGeom prst="roundRect">
             <a:avLst>
-              <a:gd name="adj" fmla="val 8696"/>
+              <a:gd name="adj" fmla="val 17778"/>
             </a:avLst>
           </a:prstGeom>
           <a:solidFill>
+            <a:srgbClr val="FBFFF4"/>
+          </a:solidFill>
+          <a:ln w="12700">
+            <a:solidFill>
+              <a:srgbClr val="FBFFF4"/>
+            </a:solidFill>
+            <a:prstDash val="solid"/>
+          </a:ln>
+        </p:spPr>
+      </p:sp>
+      <p:sp>
+        <p:nvSpPr>
+          <p:cNvPr id="8" name="Shape 5"/>
+          <p:cNvSpPr/>
+          <p:nvPr/>
+        </p:nvSpPr>
+        <p:spPr>
+          <a:xfrm>
+            <a:off x="828904" y="2093976"/>
+            <a:ext cx="146304" cy="146304"/>
+          </a:xfrm>
+          <a:prstGeom prst="roundRect">
+            <a:avLst>
+              <a:gd name="adj" fmla="val 18750"/>
+            </a:avLst>
+          </a:prstGeom>
+          <a:solidFill>
             <a:srgbClr val="DDF3B8"/>
           </a:solidFill>
-          <a:ln w="12700">
-            <a:solidFill>
-              <a:srgbClr val="DDF3B8"/>
-            </a:solidFill>
-            <a:prstDash val="solid"/>
-          </a:ln>
-        </p:spPr>
-      </p:sp>
-      <p:sp>
-        <p:nvSpPr>
-          <p:cNvPr id="6" name="Shape 3"/>
-          <p:cNvSpPr/>
-          <p:nvPr/>
-        </p:nvSpPr>
-        <p:spPr>
-          <a:xfrm>
-            <a:off x="2991002" y="1190549"/>
-            <a:ext cx="420624" cy="378562"/>
-          </a:xfrm>
-          <a:prstGeom prst="heart">
-            <a:avLst/>
-          </a:prstGeom>
-          <a:solidFill>
-            <a:srgbClr val="26720A"/>
-          </a:solidFill>
-          <a:ln w="12700">
-            <a:solidFill>
-              <a:srgbClr val="26720A"/>
-            </a:solidFill>
-            <a:prstDash val="solid"/>
-          </a:ln>
-        </p:spPr>
-      </p:sp>
-      <p:sp>
-        <p:nvSpPr>
-          <p:cNvPr id="7" name="Text 4"/>
+          <a:ln w="6350">
+            <a:solidFill>
+              <a:srgbClr val="B8D98A"/>
+            </a:solidFill>
+            <a:prstDash val="solid"/>
+          </a:ln>
+        </p:spPr>
+      </p:sp>
+      <p:sp>
+        <p:nvSpPr>
+          <p:cNvPr id="9" name="Text 6"/>
           <p:cNvSpPr txBox="1"/>
           <p:nvPr/>
         </p:nvSpPr>
         <p:spPr>
           <a:xfrm>
-            <a:off x="2927909" y="1653235"/>
-            <a:ext cx="1114654" cy="578358"/>
+            <a:off x="1066648" y="1965960"/>
+            <a:ext cx="1508760" cy="411480"/>
           </a:xfrm>
           <a:prstGeom prst="rect">
             <a:avLst/>
@@ -2677,6 +3064,111 @@
           <a:lstStyle/>
           <a:p>
             <a:pPr indent="0" marL="0">
+              <a:buNone/>
+            </a:pPr>
+            <a:r>
+              <a:rPr lang="en-US" sz="1300" dirty="0">
+                <a:solidFill>
+                  <a:srgbClr val="0E1F0C"/>
+                </a:solidFill>
+                <a:latin typeface="Poppins" pitchFamily="34" charset="0"/>
+                <a:ea typeface="Poppins" pitchFamily="34" charset="-122"/>
+                <a:cs typeface="Poppins" pitchFamily="34" charset="-120"/>
+              </a:rPr>
+              <a:t>Lenas Feed</a:t>
+            </a:r>
+            <a:endParaRPr lang="en-US" sz="1300" dirty="0"/>
+          </a:p>
+        </p:txBody>
+      </p:sp>
+      <p:sp>
+        <p:nvSpPr>
+          <p:cNvPr id="10" name="Text 7"/>
+          <p:cNvSpPr txBox="1"/>
+          <p:nvPr/>
+        </p:nvSpPr>
+        <p:spPr>
+          <a:xfrm>
+            <a:off x="746608" y="2606040"/>
+            <a:ext cx="3017520" cy="457200"/>
+          </a:xfrm>
+          <a:prstGeom prst="rect">
+            <a:avLst/>
+          </a:prstGeom>
+          <a:noFill/>
+          <a:ln/>
+        </p:spPr>
+        <p:txBody>
+          <a:bodyPr wrap="square" lIns="0" tIns="0" rIns="0" bIns="0" rtlCol="0" anchor="t"/>
+          <a:lstStyle/>
+          <a:p>
+            <a:pPr indent="0" marL="0">
+              <a:buNone/>
+            </a:pPr>
+            <a:r>
+              <a:rPr lang="en-US" sz="2200" b="1" dirty="0">
+                <a:solidFill>
+                  <a:srgbClr val="0E1F0C"/>
+                </a:solidFill>
+                <a:latin typeface="Poppins" pitchFamily="34" charset="0"/>
+                <a:ea typeface="Poppins" pitchFamily="34" charset="-122"/>
+                <a:cs typeface="Poppins" pitchFamily="34" charset="-120"/>
+              </a:rPr>
+              <a:t>Lenas Feed</a:t>
+            </a:r>
+            <a:endParaRPr lang="en-US" sz="2200" dirty="0"/>
+          </a:p>
+        </p:txBody>
+      </p:sp>
+      <p:sp>
+        <p:nvSpPr>
+          <p:cNvPr id="11" name="Shape 8"/>
+          <p:cNvSpPr/>
+          <p:nvPr/>
+        </p:nvSpPr>
+        <p:spPr>
+          <a:xfrm>
+            <a:off x="746608" y="3200400"/>
+            <a:ext cx="1554480" cy="457200"/>
+          </a:xfrm>
+          <a:prstGeom prst="roundRect">
+            <a:avLst>
+              <a:gd name="adj" fmla="val 16000"/>
+            </a:avLst>
+          </a:prstGeom>
+          <a:solidFill>
+            <a:srgbClr val="B1FF37"/>
+          </a:solidFill>
+          <a:ln w="12700">
+            <a:solidFill>
+              <a:srgbClr val="B1FF37"/>
+            </a:solidFill>
+            <a:prstDash val="solid"/>
+          </a:ln>
+        </p:spPr>
+      </p:sp>
+      <p:sp>
+        <p:nvSpPr>
+          <p:cNvPr id="12" name="Text 9"/>
+          <p:cNvSpPr txBox="1"/>
+          <p:nvPr/>
+        </p:nvSpPr>
+        <p:spPr>
+          <a:xfrm>
+            <a:off x="746608" y="3200400"/>
+            <a:ext cx="1554480" cy="457200"/>
+          </a:xfrm>
+          <a:prstGeom prst="rect">
+            <a:avLst/>
+          </a:prstGeom>
+          <a:noFill/>
+          <a:ln/>
+        </p:spPr>
+        <p:txBody>
+          <a:bodyPr wrap="square" lIns="0" tIns="0" rIns="0" bIns="0" rtlCol="0" anchor="ctr"/>
+          <a:lstStyle/>
+          <a:p>
+            <a:pPr algn="ctr" indent="0" marL="0">
               <a:buNone/>
             </a:pPr>
             <a:r>
@@ -2688,7 +3180,7 @@
                 <a:ea typeface="Poppins" pitchFamily="34" charset="-122"/>
                 <a:cs typeface="Poppins" pitchFamily="34" charset="-120"/>
               </a:rPr>
-              <a:t>Tanz-Challenge</a:t>
+              <a:t>Tanzvideos</a:t>
             </a:r>
             <a:endParaRPr lang="en-US" sz="1400" dirty="0"/>
           </a:p>
@@ -2696,66 +3188,41 @@
       </p:sp>
       <p:sp>
         <p:nvSpPr>
-          <p:cNvPr id="8" name="Shape 5"/>
-          <p:cNvSpPr/>
-          <p:nvPr/>
-        </p:nvSpPr>
-        <p:spPr>
-          <a:xfrm>
-            <a:off x="2801722" y="2473452"/>
-            <a:ext cx="1367028" cy="1261872"/>
+          <p:cNvPr id="13" name="Shape 10"/>
+          <p:cNvSpPr/>
+          <p:nvPr/>
+        </p:nvSpPr>
+        <p:spPr>
+          <a:xfrm>
+            <a:off x="2438248" y="3200400"/>
+            <a:ext cx="1188720" cy="457200"/>
           </a:xfrm>
           <a:prstGeom prst="roundRect">
             <a:avLst>
-              <a:gd name="adj" fmla="val 8696"/>
+              <a:gd name="adj" fmla="val 16000"/>
             </a:avLst>
           </a:prstGeom>
           <a:solidFill>
-            <a:srgbClr val="DDF3B8"/>
+            <a:srgbClr val="B1FF37"/>
           </a:solidFill>
           <a:ln w="12700">
             <a:solidFill>
-              <a:srgbClr val="DDF3B8"/>
-            </a:solidFill>
-            <a:prstDash val="solid"/>
-          </a:ln>
-        </p:spPr>
-      </p:sp>
-      <p:sp>
-        <p:nvSpPr>
-          <p:cNvPr id="9" name="Shape 6"/>
-          <p:cNvSpPr/>
-          <p:nvPr/>
-        </p:nvSpPr>
-        <p:spPr>
-          <a:xfrm>
-            <a:off x="2991002" y="2662733"/>
-            <a:ext cx="420624" cy="378562"/>
-          </a:xfrm>
-          <a:prstGeom prst="heart">
-            <a:avLst/>
-          </a:prstGeom>
-          <a:solidFill>
-            <a:srgbClr val="26720A"/>
-          </a:solidFill>
-          <a:ln w="12700">
-            <a:solidFill>
-              <a:srgbClr val="26720A"/>
-            </a:solidFill>
-            <a:prstDash val="solid"/>
-          </a:ln>
-        </p:spPr>
-      </p:sp>
-      <p:sp>
-        <p:nvSpPr>
-          <p:cNvPr id="10" name="Text 7"/>
+              <a:srgbClr val="B1FF37"/>
+            </a:solidFill>
+            <a:prstDash val="solid"/>
+          </a:ln>
+        </p:spPr>
+      </p:sp>
+      <p:sp>
+        <p:nvSpPr>
+          <p:cNvPr id="14" name="Text 11"/>
           <p:cNvSpPr txBox="1"/>
           <p:nvPr/>
         </p:nvSpPr>
         <p:spPr>
           <a:xfrm>
-            <a:off x="2927909" y="3125419"/>
-            <a:ext cx="1114654" cy="578358"/>
+            <a:off x="2438248" y="3200400"/>
+            <a:ext cx="1188720" cy="457200"/>
           </a:xfrm>
           <a:prstGeom prst="rect">
             <a:avLst/>
@@ -2767,7 +3234,7 @@
           <a:bodyPr wrap="square" lIns="0" tIns="0" rIns="0" bIns="0" rtlCol="0" anchor="ctr"/>
           <a:lstStyle/>
           <a:p>
-            <a:pPr indent="0" marL="0">
+            <a:pPr algn="ctr" indent="0" marL="0">
               <a:buNone/>
             </a:pPr>
             <a:r>
@@ -2779,7 +3246,7 @@
                 <a:ea typeface="Poppins" pitchFamily="34" charset="-122"/>
                 <a:cs typeface="Poppins" pitchFamily="34" charset="-120"/>
               </a:rPr>
-              <a:t>Choreo lernen</a:t>
+              <a:t>Choreo</a:t>
             </a:r>
             <a:endParaRPr lang="en-US" sz="1400" dirty="0"/>
           </a:p>
@@ -2787,66 +3254,41 @@
       </p:sp>
       <p:sp>
         <p:nvSpPr>
-          <p:cNvPr id="11" name="Shape 8"/>
-          <p:cNvSpPr/>
-          <p:nvPr/>
-        </p:nvSpPr>
-        <p:spPr>
-          <a:xfrm>
-            <a:off x="2801722" y="3945636"/>
-            <a:ext cx="1367028" cy="1261872"/>
+          <p:cNvPr id="15" name="Shape 12"/>
+          <p:cNvSpPr/>
+          <p:nvPr/>
+        </p:nvSpPr>
+        <p:spPr>
+          <a:xfrm>
+            <a:off x="746608" y="3794760"/>
+            <a:ext cx="1645920" cy="457200"/>
           </a:xfrm>
           <a:prstGeom prst="roundRect">
             <a:avLst>
-              <a:gd name="adj" fmla="val 8696"/>
+              <a:gd name="adj" fmla="val 16000"/>
             </a:avLst>
           </a:prstGeom>
           <a:solidFill>
-            <a:srgbClr val="DDF3B8"/>
+            <a:srgbClr val="B1FF37"/>
           </a:solidFill>
           <a:ln w="12700">
             <a:solidFill>
-              <a:srgbClr val="DDF3B8"/>
-            </a:solidFill>
-            <a:prstDash val="solid"/>
-          </a:ln>
-        </p:spPr>
-      </p:sp>
-      <p:sp>
-        <p:nvSpPr>
-          <p:cNvPr id="12" name="Shape 9"/>
-          <p:cNvSpPr/>
-          <p:nvPr/>
-        </p:nvSpPr>
-        <p:spPr>
-          <a:xfrm>
-            <a:off x="2991002" y="4134917"/>
-            <a:ext cx="420624" cy="378562"/>
-          </a:xfrm>
-          <a:prstGeom prst="heart">
-            <a:avLst/>
-          </a:prstGeom>
-          <a:solidFill>
-            <a:srgbClr val="26720A"/>
-          </a:solidFill>
-          <a:ln w="12700">
-            <a:solidFill>
-              <a:srgbClr val="26720A"/>
-            </a:solidFill>
-            <a:prstDash val="solid"/>
-          </a:ln>
-        </p:spPr>
-      </p:sp>
-      <p:sp>
-        <p:nvSpPr>
-          <p:cNvPr id="13" name="Text 10"/>
+              <a:srgbClr val="B1FF37"/>
+            </a:solidFill>
+            <a:prstDash val="solid"/>
+          </a:ln>
+        </p:spPr>
+      </p:sp>
+      <p:sp>
+        <p:nvSpPr>
+          <p:cNvPr id="16" name="Text 13"/>
           <p:cNvSpPr txBox="1"/>
           <p:nvPr/>
         </p:nvSpPr>
         <p:spPr>
           <a:xfrm>
-            <a:off x="2927909" y="4597603"/>
-            <a:ext cx="1114654" cy="578358"/>
+            <a:off x="746608" y="3794760"/>
+            <a:ext cx="1645920" cy="457200"/>
           </a:xfrm>
           <a:prstGeom prst="rect">
             <a:avLst/>
@@ -2858,7 +3300,7 @@
           <a:bodyPr wrap="square" lIns="0" tIns="0" rIns="0" bIns="0" rtlCol="0" anchor="ctr"/>
           <a:lstStyle/>
           <a:p>
-            <a:pPr indent="0" marL="0">
+            <a:pPr algn="ctr" indent="0" marL="0">
               <a:buNone/>
             </a:pPr>
             <a:r>
@@ -2878,14 +3320,14 @@
       </p:sp>
       <p:sp>
         <p:nvSpPr>
-          <p:cNvPr id="14" name="Text 11"/>
+          <p:cNvPr id="17" name="Text 14"/>
           <p:cNvSpPr txBox="1"/>
           <p:nvPr/>
         </p:nvSpPr>
         <p:spPr>
           <a:xfrm>
-            <a:off x="2408530" y="5811012"/>
-            <a:ext cx="2153412" cy="411480"/>
+            <a:off x="746608" y="4754880"/>
+            <a:ext cx="3017520" cy="457200"/>
           </a:xfrm>
           <a:prstGeom prst="rect">
             <a:avLst/>
@@ -2897,21 +3339,21 @@
           <a:bodyPr wrap="square" lIns="0" tIns="0" rIns="0" bIns="0" rtlCol="0" anchor="t"/>
           <a:lstStyle/>
           <a:p>
-            <a:pPr algn="ctr" indent="0" marL="0">
+            <a:pPr indent="0" marL="0">
               <a:buNone/>
             </a:pPr>
             <a:r>
-              <a:rPr lang="en-US" sz="2000" b="1" dirty="0">
+              <a:rPr lang="en-US" sz="1400" dirty="0">
                 <a:solidFill>
-                  <a:srgbClr val="0E1F0C"/>
+                  <a:srgbClr val="5B6B50"/>
                 </a:solidFill>
                 <a:latin typeface="Poppins" pitchFamily="34" charset="0"/>
                 <a:ea typeface="Poppins" pitchFamily="34" charset="-122"/>
                 <a:cs typeface="Poppins" pitchFamily="34" charset="-120"/>
               </a:rPr>
-              <a:t>Lenas Feed</a:t>
-            </a:r>
-            <a:endParaRPr lang="en-US" sz="2000" dirty="0"/>
+              <a:t>Immer wieder Tanz.</a:t>
+            </a:r>
+            <a:endParaRPr lang="en-US" sz="1400" dirty="0"/>
           </a:p>
         </p:txBody>
       </p:sp>
@@ -2948,20 +3390,20 @@
         </p:nvSpPr>
         <p:spPr>
           <a:xfrm>
-            <a:off x="5202022" y="685800"/>
-            <a:ext cx="1787652" cy="4942332"/>
+            <a:off x="4358488" y="1508760"/>
+            <a:ext cx="3474720" cy="3840480"/>
           </a:xfrm>
           <a:prstGeom prst="roundRect">
             <a:avLst>
-              <a:gd name="adj" fmla="val 15345"/>
+              <a:gd name="adj" fmla="val 3158"/>
             </a:avLst>
           </a:prstGeom>
           <a:solidFill>
-            <a:srgbClr val="12301A"/>
-          </a:solidFill>
-          <a:ln w="12700">
-            <a:solidFill>
-              <a:srgbClr val="12301A"/>
+            <a:srgbClr val="FBFFF4"/>
+          </a:solidFill>
+          <a:ln w="15875">
+            <a:solidFill>
+              <a:srgbClr val="B8D98A"/>
             </a:solidFill>
             <a:prstDash val="solid"/>
           </a:ln>
@@ -2975,20 +3417,20 @@
         </p:nvSpPr>
         <p:spPr>
           <a:xfrm>
-            <a:off x="5293462" y="777240"/>
-            <a:ext cx="1604772" cy="4759452"/>
+            <a:off x="4358488" y="1508760"/>
+            <a:ext cx="3474720" cy="822960"/>
           </a:xfrm>
           <a:prstGeom prst="roundRect">
             <a:avLst>
-              <a:gd name="adj" fmla="val 12536"/>
+              <a:gd name="adj" fmla="val 13333"/>
             </a:avLst>
           </a:prstGeom>
           <a:solidFill>
-            <a:srgbClr val="FBFFF4"/>
+            <a:srgbClr val="12301A"/>
           </a:solidFill>
           <a:ln w="12700">
             <a:solidFill>
-              <a:srgbClr val="FBFFF4"/>
+              <a:srgbClr val="12301A"/>
             </a:solidFill>
             <a:prstDash val="solid"/>
           </a:ln>
@@ -3002,60 +3444,126 @@
         </p:nvSpPr>
         <p:spPr>
           <a:xfrm>
-            <a:off x="5412334" y="1001268"/>
-            <a:ext cx="1367028" cy="1261872"/>
+            <a:off x="4367632" y="1920240"/>
+            <a:ext cx="3456432" cy="457200"/>
+          </a:xfrm>
+          <a:prstGeom prst="rect">
+            <a:avLst/>
+          </a:prstGeom>
+          <a:solidFill>
+            <a:srgbClr val="DDF3B8"/>
+          </a:solidFill>
+          <a:ln w="12700">
+            <a:solidFill>
+              <a:srgbClr val="DDF3B8"/>
+            </a:solidFill>
+            <a:prstDash val="solid"/>
+          </a:ln>
+        </p:spPr>
+      </p:sp>
+      <p:sp>
+        <p:nvSpPr>
+          <p:cNvPr id="6" name="Text 3"/>
+          <p:cNvSpPr txBox="1"/>
+          <p:nvPr/>
+        </p:nvSpPr>
+        <p:spPr>
+          <a:xfrm>
+            <a:off x="5638648" y="1563624"/>
+            <a:ext cx="2011680" cy="310896"/>
+          </a:xfrm>
+          <a:prstGeom prst="rect">
+            <a:avLst/>
+          </a:prstGeom>
+          <a:noFill/>
+          <a:ln/>
+        </p:spPr>
+        <p:txBody>
+          <a:bodyPr wrap="square" lIns="0" tIns="0" rIns="0" bIns="0" rtlCol="0" anchor="ctr"/>
+          <a:lstStyle/>
+          <a:p>
+            <a:pPr algn="r" indent="0" marL="0">
+              <a:buNone/>
+            </a:pPr>
+            <a:r>
+              <a:rPr lang="en-US" sz="1300" dirty="0">
+                <a:solidFill>
+                  <a:srgbClr val="FBFFF4"/>
+                </a:solidFill>
+                <a:latin typeface="Poppins" pitchFamily="34" charset="0"/>
+                <a:ea typeface="Poppins" pitchFamily="34" charset="-122"/>
+                <a:cs typeface="Poppins" pitchFamily="34" charset="-120"/>
+              </a:rPr>
+              <a:t>Für dich</a:t>
+            </a:r>
+            <a:endParaRPr lang="en-US" sz="1300" dirty="0"/>
+          </a:p>
+        </p:txBody>
+      </p:sp>
+      <p:sp>
+        <p:nvSpPr>
+          <p:cNvPr id="7" name="Shape 4"/>
+          <p:cNvSpPr/>
+          <p:nvPr/>
+        </p:nvSpPr>
+        <p:spPr>
+          <a:xfrm>
+            <a:off x="4541368" y="1965960"/>
+            <a:ext cx="1920240" cy="411480"/>
           </a:xfrm>
           <a:prstGeom prst="roundRect">
             <a:avLst>
-              <a:gd name="adj" fmla="val 8696"/>
+              <a:gd name="adj" fmla="val 17778"/>
             </a:avLst>
           </a:prstGeom>
           <a:solidFill>
+            <a:srgbClr val="FBFFF4"/>
+          </a:solidFill>
+          <a:ln w="12700">
+            <a:solidFill>
+              <a:srgbClr val="FBFFF4"/>
+            </a:solidFill>
+            <a:prstDash val="solid"/>
+          </a:ln>
+        </p:spPr>
+      </p:sp>
+      <p:sp>
+        <p:nvSpPr>
+          <p:cNvPr id="8" name="Shape 5"/>
+          <p:cNvSpPr/>
+          <p:nvPr/>
+        </p:nvSpPr>
+        <p:spPr>
+          <a:xfrm>
+            <a:off x="4669384" y="2093976"/>
+            <a:ext cx="146304" cy="146304"/>
+          </a:xfrm>
+          <a:prstGeom prst="roundRect">
+            <a:avLst>
+              <a:gd name="adj" fmla="val 18750"/>
+            </a:avLst>
+          </a:prstGeom>
+          <a:solidFill>
             <a:srgbClr val="DDF3B8"/>
           </a:solidFill>
-          <a:ln w="12700">
-            <a:solidFill>
-              <a:srgbClr val="DDF3B8"/>
-            </a:solidFill>
-            <a:prstDash val="solid"/>
-          </a:ln>
-        </p:spPr>
-      </p:sp>
-      <p:sp>
-        <p:nvSpPr>
-          <p:cNvPr id="6" name="Shape 3"/>
-          <p:cNvSpPr/>
-          <p:nvPr/>
-        </p:nvSpPr>
-        <p:spPr>
-          <a:xfrm>
-            <a:off x="5601614" y="1169518"/>
-            <a:ext cx="420624" cy="420624"/>
-          </a:xfrm>
-          <a:prstGeom prst="ellipse">
-            <a:avLst/>
-          </a:prstGeom>
-          <a:solidFill>
-            <a:srgbClr val="26720A"/>
-          </a:solidFill>
-          <a:ln w="12700">
-            <a:solidFill>
-              <a:srgbClr val="26720A"/>
-            </a:solidFill>
-            <a:prstDash val="solid"/>
-          </a:ln>
-        </p:spPr>
-      </p:sp>
-      <p:sp>
-        <p:nvSpPr>
-          <p:cNvPr id="7" name="Text 4"/>
+          <a:ln w="6350">
+            <a:solidFill>
+              <a:srgbClr val="B8D98A"/>
+            </a:solidFill>
+            <a:prstDash val="solid"/>
+          </a:ln>
+        </p:spPr>
+      </p:sp>
+      <p:sp>
+        <p:nvSpPr>
+          <p:cNvPr id="9" name="Text 6"/>
           <p:cNvSpPr txBox="1"/>
           <p:nvPr/>
         </p:nvSpPr>
         <p:spPr>
           <a:xfrm>
-            <a:off x="5538521" y="1653235"/>
-            <a:ext cx="1114654" cy="578358"/>
+            <a:off x="4907128" y="1965960"/>
+            <a:ext cx="1508760" cy="411480"/>
           </a:xfrm>
           <a:prstGeom prst="rect">
             <a:avLst/>
@@ -3068,6 +3576,243 @@
           <a:lstStyle/>
           <a:p>
             <a:pPr indent="0" marL="0">
+              <a:buNone/>
+            </a:pPr>
+            <a:r>
+              <a:rPr lang="en-US" sz="1300" dirty="0">
+                <a:solidFill>
+                  <a:srgbClr val="0E1F0C"/>
+                </a:solidFill>
+                <a:latin typeface="Poppins" pitchFamily="34" charset="0"/>
+                <a:ea typeface="Poppins" pitchFamily="34" charset="-122"/>
+                <a:cs typeface="Poppins" pitchFamily="34" charset="-120"/>
+              </a:rPr>
+              <a:t>Jonas’ Feed</a:t>
+            </a:r>
+            <a:endParaRPr lang="en-US" sz="1300" dirty="0"/>
+          </a:p>
+        </p:txBody>
+      </p:sp>
+      <p:sp>
+        <p:nvSpPr>
+          <p:cNvPr id="10" name="Text 7"/>
+          <p:cNvSpPr txBox="1"/>
+          <p:nvPr/>
+        </p:nvSpPr>
+        <p:spPr>
+          <a:xfrm>
+            <a:off x="4587088" y="2606040"/>
+            <a:ext cx="3017520" cy="457200"/>
+          </a:xfrm>
+          <a:prstGeom prst="rect">
+            <a:avLst/>
+          </a:prstGeom>
+          <a:noFill/>
+          <a:ln/>
+        </p:spPr>
+        <p:txBody>
+          <a:bodyPr wrap="square" lIns="0" tIns="0" rIns="0" bIns="0" rtlCol="0" anchor="t"/>
+          <a:lstStyle/>
+          <a:p>
+            <a:pPr indent="0" marL="0">
+              <a:buNone/>
+            </a:pPr>
+            <a:r>
+              <a:rPr lang="en-US" sz="2200" b="1" dirty="0">
+                <a:solidFill>
+                  <a:srgbClr val="0E1F0C"/>
+                </a:solidFill>
+                <a:latin typeface="Poppins" pitchFamily="34" charset="0"/>
+                <a:ea typeface="Poppins" pitchFamily="34" charset="-122"/>
+                <a:cs typeface="Poppins" pitchFamily="34" charset="-120"/>
+              </a:rPr>
+              <a:t>Jonas’ Feed</a:t>
+            </a:r>
+            <a:endParaRPr lang="en-US" sz="2200" dirty="0"/>
+          </a:p>
+        </p:txBody>
+      </p:sp>
+      <p:sp>
+        <p:nvSpPr>
+          <p:cNvPr id="11" name="Shape 8"/>
+          <p:cNvSpPr/>
+          <p:nvPr/>
+        </p:nvSpPr>
+        <p:spPr>
+          <a:xfrm>
+            <a:off x="4587088" y="3200400"/>
+            <a:ext cx="1280160" cy="457200"/>
+          </a:xfrm>
+          <a:prstGeom prst="roundRect">
+            <a:avLst>
+              <a:gd name="adj" fmla="val 16000"/>
+            </a:avLst>
+          </a:prstGeom>
+          <a:solidFill>
+            <a:srgbClr val="B1FF37"/>
+          </a:solidFill>
+          <a:ln w="12700">
+            <a:solidFill>
+              <a:srgbClr val="B1FF37"/>
+            </a:solidFill>
+            <a:prstDash val="solid"/>
+          </a:ln>
+        </p:spPr>
+      </p:sp>
+      <p:sp>
+        <p:nvSpPr>
+          <p:cNvPr id="12" name="Text 9"/>
+          <p:cNvSpPr txBox="1"/>
+          <p:nvPr/>
+        </p:nvSpPr>
+        <p:spPr>
+          <a:xfrm>
+            <a:off x="4587088" y="3200400"/>
+            <a:ext cx="1280160" cy="457200"/>
+          </a:xfrm>
+          <a:prstGeom prst="rect">
+            <a:avLst/>
+          </a:prstGeom>
+          <a:noFill/>
+          <a:ln/>
+        </p:spPr>
+        <p:txBody>
+          <a:bodyPr wrap="square" lIns="0" tIns="0" rIns="0" bIns="0" rtlCol="0" anchor="ctr"/>
+          <a:lstStyle/>
+          <a:p>
+            <a:pPr algn="ctr" indent="0" marL="0">
+              <a:buNone/>
+            </a:pPr>
+            <a:r>
+              <a:rPr lang="en-US" sz="1400" b="1" dirty="0">
+                <a:solidFill>
+                  <a:srgbClr val="0E1F0C"/>
+                </a:solidFill>
+                <a:latin typeface="Poppins" pitchFamily="34" charset="0"/>
+                <a:ea typeface="Poppins" pitchFamily="34" charset="-122"/>
+                <a:cs typeface="Poppins" pitchFamily="34" charset="-120"/>
+              </a:rPr>
+              <a:t>Fußball</a:t>
+            </a:r>
+            <a:endParaRPr lang="en-US" sz="1400" dirty="0"/>
+          </a:p>
+        </p:txBody>
+      </p:sp>
+      <p:sp>
+        <p:nvSpPr>
+          <p:cNvPr id="13" name="Shape 10"/>
+          <p:cNvSpPr/>
+          <p:nvPr/>
+        </p:nvSpPr>
+        <p:spPr>
+          <a:xfrm>
+            <a:off x="6004408" y="3200400"/>
+            <a:ext cx="914400" cy="457200"/>
+          </a:xfrm>
+          <a:prstGeom prst="roundRect">
+            <a:avLst>
+              <a:gd name="adj" fmla="val 16000"/>
+            </a:avLst>
+          </a:prstGeom>
+          <a:solidFill>
+            <a:srgbClr val="B1FF37"/>
+          </a:solidFill>
+          <a:ln w="12700">
+            <a:solidFill>
+              <a:srgbClr val="B1FF37"/>
+            </a:solidFill>
+            <a:prstDash val="solid"/>
+          </a:ln>
+        </p:spPr>
+      </p:sp>
+      <p:sp>
+        <p:nvSpPr>
+          <p:cNvPr id="14" name="Text 11"/>
+          <p:cNvSpPr txBox="1"/>
+          <p:nvPr/>
+        </p:nvSpPr>
+        <p:spPr>
+          <a:xfrm>
+            <a:off x="6004408" y="3200400"/>
+            <a:ext cx="914400" cy="457200"/>
+          </a:xfrm>
+          <a:prstGeom prst="rect">
+            <a:avLst/>
+          </a:prstGeom>
+          <a:noFill/>
+          <a:ln/>
+        </p:spPr>
+        <p:txBody>
+          <a:bodyPr wrap="square" lIns="0" tIns="0" rIns="0" bIns="0" rtlCol="0" anchor="ctr"/>
+          <a:lstStyle/>
+          <a:p>
+            <a:pPr algn="ctr" indent="0" marL="0">
+              <a:buNone/>
+            </a:pPr>
+            <a:r>
+              <a:rPr lang="en-US" sz="1400" b="1" dirty="0">
+                <a:solidFill>
+                  <a:srgbClr val="0E1F0C"/>
+                </a:solidFill>
+                <a:latin typeface="Poppins" pitchFamily="34" charset="0"/>
+                <a:ea typeface="Poppins" pitchFamily="34" charset="-122"/>
+                <a:cs typeface="Poppins" pitchFamily="34" charset="-120"/>
+              </a:rPr>
+              <a:t>Tore</a:t>
+            </a:r>
+            <a:endParaRPr lang="en-US" sz="1400" dirty="0"/>
+          </a:p>
+        </p:txBody>
+      </p:sp>
+      <p:sp>
+        <p:nvSpPr>
+          <p:cNvPr id="15" name="Shape 12"/>
+          <p:cNvSpPr/>
+          <p:nvPr/>
+        </p:nvSpPr>
+        <p:spPr>
+          <a:xfrm>
+            <a:off x="4587088" y="3794760"/>
+            <a:ext cx="2011680" cy="457200"/>
+          </a:xfrm>
+          <a:prstGeom prst="roundRect">
+            <a:avLst>
+              <a:gd name="adj" fmla="val 16000"/>
+            </a:avLst>
+          </a:prstGeom>
+          <a:solidFill>
+            <a:srgbClr val="B1FF37"/>
+          </a:solidFill>
+          <a:ln w="12700">
+            <a:solidFill>
+              <a:srgbClr val="B1FF37"/>
+            </a:solidFill>
+            <a:prstDash val="solid"/>
+          </a:ln>
+        </p:spPr>
+      </p:sp>
+      <p:sp>
+        <p:nvSpPr>
+          <p:cNvPr id="16" name="Text 13"/>
+          <p:cNvSpPr txBox="1"/>
+          <p:nvPr/>
+        </p:nvSpPr>
+        <p:spPr>
+          <a:xfrm>
+            <a:off x="4587088" y="3794760"/>
+            <a:ext cx="2011680" cy="457200"/>
+          </a:xfrm>
+          <a:prstGeom prst="rect">
+            <a:avLst/>
+          </a:prstGeom>
+          <a:noFill/>
+          <a:ln/>
+        </p:spPr>
+        <p:txBody>
+          <a:bodyPr wrap="square" lIns="0" tIns="0" rIns="0" bIns="0" rtlCol="0" anchor="ctr"/>
+          <a:lstStyle/>
+          <a:p>
+            <a:pPr algn="ctr" indent="0" marL="0">
               <a:buNone/>
             </a:pPr>
             <a:r>
@@ -3087,66 +3832,14 @@
       </p:sp>
       <p:sp>
         <p:nvSpPr>
-          <p:cNvPr id="8" name="Shape 5"/>
-          <p:cNvSpPr/>
-          <p:nvPr/>
-        </p:nvSpPr>
-        <p:spPr>
-          <a:xfrm>
-            <a:off x="5412334" y="2473452"/>
-            <a:ext cx="1367028" cy="1261872"/>
-          </a:xfrm>
-          <a:prstGeom prst="roundRect">
-            <a:avLst>
-              <a:gd name="adj" fmla="val 8696"/>
-            </a:avLst>
-          </a:prstGeom>
-          <a:solidFill>
-            <a:srgbClr val="DDF3B8"/>
-          </a:solidFill>
-          <a:ln w="12700">
-            <a:solidFill>
-              <a:srgbClr val="DDF3B8"/>
-            </a:solidFill>
-            <a:prstDash val="solid"/>
-          </a:ln>
-        </p:spPr>
-      </p:sp>
-      <p:sp>
-        <p:nvSpPr>
-          <p:cNvPr id="9" name="Shape 6"/>
-          <p:cNvSpPr/>
-          <p:nvPr/>
-        </p:nvSpPr>
-        <p:spPr>
-          <a:xfrm>
-            <a:off x="5601614" y="2641702"/>
-            <a:ext cx="420624" cy="420624"/>
-          </a:xfrm>
-          <a:prstGeom prst="ellipse">
-            <a:avLst/>
-          </a:prstGeom>
-          <a:solidFill>
-            <a:srgbClr val="26720A"/>
-          </a:solidFill>
-          <a:ln w="12700">
-            <a:solidFill>
-              <a:srgbClr val="26720A"/>
-            </a:solidFill>
-            <a:prstDash val="solid"/>
-          </a:ln>
-        </p:spPr>
-      </p:sp>
-      <p:sp>
-        <p:nvSpPr>
-          <p:cNvPr id="10" name="Text 7"/>
+          <p:cNvPr id="17" name="Text 14"/>
           <p:cNvSpPr txBox="1"/>
           <p:nvPr/>
         </p:nvSpPr>
         <p:spPr>
           <a:xfrm>
-            <a:off x="5538521" y="3125419"/>
-            <a:ext cx="1114654" cy="578358"/>
+            <a:off x="4587088" y="4754880"/>
+            <a:ext cx="3017520" cy="457200"/>
           </a:xfrm>
           <a:prstGeom prst="rect">
             <a:avLst/>
@@ -3155,154 +3848,24 @@
           <a:ln/>
         </p:spPr>
         <p:txBody>
-          <a:bodyPr wrap="square" lIns="0" tIns="0" rIns="0" bIns="0" rtlCol="0" anchor="ctr"/>
+          <a:bodyPr wrap="square" lIns="0" tIns="0" rIns="0" bIns="0" rtlCol="0" anchor="t"/>
           <a:lstStyle/>
           <a:p>
             <a:pPr indent="0" marL="0">
               <a:buNone/>
             </a:pPr>
             <a:r>
-              <a:rPr lang="en-US" sz="1400" b="1" dirty="0">
+              <a:rPr lang="en-US" sz="1400" dirty="0">
                 <a:solidFill>
-                  <a:srgbClr val="0E1F0C"/>
+                  <a:srgbClr val="5B6B50"/>
                 </a:solidFill>
                 <a:latin typeface="Poppins" pitchFamily="34" charset="0"/>
                 <a:ea typeface="Poppins" pitchFamily="34" charset="-122"/>
                 <a:cs typeface="Poppins" pitchFamily="34" charset="-120"/>
               </a:rPr>
-              <a:t>Tor des Monats</a:t>
+              <a:t>Fast nur Fußball.</a:t>
             </a:r>
             <a:endParaRPr lang="en-US" sz="1400" dirty="0"/>
-          </a:p>
-        </p:txBody>
-      </p:sp>
-      <p:sp>
-        <p:nvSpPr>
-          <p:cNvPr id="11" name="Shape 8"/>
-          <p:cNvSpPr/>
-          <p:nvPr/>
-        </p:nvSpPr>
-        <p:spPr>
-          <a:xfrm>
-            <a:off x="5412334" y="3945636"/>
-            <a:ext cx="1367028" cy="1261872"/>
-          </a:xfrm>
-          <a:prstGeom prst="roundRect">
-            <a:avLst>
-              <a:gd name="adj" fmla="val 8696"/>
-            </a:avLst>
-          </a:prstGeom>
-          <a:solidFill>
-            <a:srgbClr val="DDF3B8"/>
-          </a:solidFill>
-          <a:ln w="12700">
-            <a:solidFill>
-              <a:srgbClr val="DDF3B8"/>
-            </a:solidFill>
-            <a:prstDash val="solid"/>
-          </a:ln>
-        </p:spPr>
-      </p:sp>
-      <p:sp>
-        <p:nvSpPr>
-          <p:cNvPr id="12" name="Shape 9"/>
-          <p:cNvSpPr/>
-          <p:nvPr/>
-        </p:nvSpPr>
-        <p:spPr>
-          <a:xfrm>
-            <a:off x="5601614" y="4113886"/>
-            <a:ext cx="420624" cy="420624"/>
-          </a:xfrm>
-          <a:prstGeom prst="ellipse">
-            <a:avLst/>
-          </a:prstGeom>
-          <a:solidFill>
-            <a:srgbClr val="26720A"/>
-          </a:solidFill>
-          <a:ln w="12700">
-            <a:solidFill>
-              <a:srgbClr val="26720A"/>
-            </a:solidFill>
-            <a:prstDash val="solid"/>
-          </a:ln>
-        </p:spPr>
-      </p:sp>
-      <p:sp>
-        <p:nvSpPr>
-          <p:cNvPr id="13" name="Text 10"/>
-          <p:cNvSpPr txBox="1"/>
-          <p:nvPr/>
-        </p:nvSpPr>
-        <p:spPr>
-          <a:xfrm>
-            <a:off x="5538521" y="4597603"/>
-            <a:ext cx="1114654" cy="578358"/>
-          </a:xfrm>
-          <a:prstGeom prst="rect">
-            <a:avLst/>
-          </a:prstGeom>
-          <a:noFill/>
-          <a:ln/>
-        </p:spPr>
-        <p:txBody>
-          <a:bodyPr wrap="square" lIns="0" tIns="0" rIns="0" bIns="0" rtlCol="0" anchor="ctr"/>
-          <a:lstStyle/>
-          <a:p>
-            <a:pPr indent="0" marL="0">
-              <a:buNone/>
-            </a:pPr>
-            <a:r>
-              <a:rPr lang="en-US" sz="1400" b="1" dirty="0">
-                <a:solidFill>
-                  <a:srgbClr val="0E1F0C"/>
-                </a:solidFill>
-                <a:latin typeface="Poppins" pitchFamily="34" charset="0"/>
-                <a:ea typeface="Poppins" pitchFamily="34" charset="-122"/>
-                <a:cs typeface="Poppins" pitchFamily="34" charset="-120"/>
-              </a:rPr>
-              <a:t>Highlights</a:t>
-            </a:r>
-            <a:endParaRPr lang="en-US" sz="1400" dirty="0"/>
-          </a:p>
-        </p:txBody>
-      </p:sp>
-      <p:sp>
-        <p:nvSpPr>
-          <p:cNvPr id="14" name="Text 11"/>
-          <p:cNvSpPr txBox="1"/>
-          <p:nvPr/>
-        </p:nvSpPr>
-        <p:spPr>
-          <a:xfrm>
-            <a:off x="5019142" y="5811012"/>
-            <a:ext cx="2153412" cy="411480"/>
-          </a:xfrm>
-          <a:prstGeom prst="rect">
-            <a:avLst/>
-          </a:prstGeom>
-          <a:noFill/>
-          <a:ln/>
-        </p:spPr>
-        <p:txBody>
-          <a:bodyPr wrap="square" lIns="0" tIns="0" rIns="0" bIns="0" rtlCol="0" anchor="t"/>
-          <a:lstStyle/>
-          <a:p>
-            <a:pPr algn="ctr" indent="0" marL="0">
-              <a:buNone/>
-            </a:pPr>
-            <a:r>
-              <a:rPr lang="en-US" sz="2000" b="1" dirty="0">
-                <a:solidFill>
-                  <a:srgbClr val="0E1F0C"/>
-                </a:solidFill>
-                <a:latin typeface="Poppins" pitchFamily="34" charset="0"/>
-                <a:ea typeface="Poppins" pitchFamily="34" charset="-122"/>
-                <a:cs typeface="Poppins" pitchFamily="34" charset="-120"/>
-              </a:rPr>
-              <a:t>Jonas’ Feed</a:t>
-            </a:r>
-            <a:endParaRPr lang="en-US" sz="2000" dirty="0"/>
           </a:p>
         </p:txBody>
       </p:sp>
@@ -3339,20 +3902,20 @@
         </p:nvSpPr>
         <p:spPr>
           <a:xfrm>
-            <a:off x="7812634" y="685800"/>
-            <a:ext cx="1787652" cy="4942332"/>
+            <a:off x="8198968" y="1508760"/>
+            <a:ext cx="3474720" cy="3840480"/>
           </a:xfrm>
           <a:prstGeom prst="roundRect">
             <a:avLst>
-              <a:gd name="adj" fmla="val 15345"/>
+              <a:gd name="adj" fmla="val 3158"/>
             </a:avLst>
           </a:prstGeom>
           <a:solidFill>
-            <a:srgbClr val="12301A"/>
-          </a:solidFill>
-          <a:ln w="12700">
-            <a:solidFill>
-              <a:srgbClr val="12301A"/>
+            <a:srgbClr val="FBFFF4"/>
+          </a:solidFill>
+          <a:ln w="15875">
+            <a:solidFill>
+              <a:srgbClr val="B8D98A"/>
             </a:solidFill>
             <a:prstDash val="solid"/>
           </a:ln>
@@ -3366,20 +3929,20 @@
         </p:nvSpPr>
         <p:spPr>
           <a:xfrm>
-            <a:off x="7904074" y="777240"/>
-            <a:ext cx="1604772" cy="4759452"/>
+            <a:off x="8198968" y="1508760"/>
+            <a:ext cx="3474720" cy="822960"/>
           </a:xfrm>
           <a:prstGeom prst="roundRect">
             <a:avLst>
-              <a:gd name="adj" fmla="val 12536"/>
+              <a:gd name="adj" fmla="val 13333"/>
             </a:avLst>
           </a:prstGeom>
           <a:solidFill>
-            <a:srgbClr val="FBFFF4"/>
+            <a:srgbClr val="12301A"/>
           </a:solidFill>
           <a:ln w="12700">
             <a:solidFill>
-              <a:srgbClr val="FBFFF4"/>
+              <a:srgbClr val="12301A"/>
             </a:solidFill>
             <a:prstDash val="solid"/>
           </a:ln>
@@ -3393,20 +3956,18 @@
         </p:nvSpPr>
         <p:spPr>
           <a:xfrm>
-            <a:off x="8022946" y="1001268"/>
-            <a:ext cx="1367028" cy="1261872"/>
-          </a:xfrm>
-          <a:prstGeom prst="roundRect">
-            <a:avLst>
-              <a:gd name="adj" fmla="val 8696"/>
-            </a:avLst>
-          </a:prstGeom>
-          <a:solidFill>
-            <a:srgbClr val="B1FF37"/>
+            <a:off x="8208112" y="1920240"/>
+            <a:ext cx="3456432" cy="457200"/>
+          </a:xfrm>
+          <a:prstGeom prst="rect">
+            <a:avLst/>
+          </a:prstGeom>
+          <a:solidFill>
+            <a:srgbClr val="DDF3B8"/>
           </a:solidFill>
           <a:ln w="12700">
             <a:solidFill>
-              <a:srgbClr val="B1FF37"/>
+              <a:srgbClr val="DDF3B8"/>
             </a:solidFill>
             <a:prstDash val="solid"/>
           </a:ln>
@@ -3420,8 +3981,8 @@
         </p:nvSpPr>
         <p:spPr>
           <a:xfrm>
-            <a:off x="8159648" y="1053846"/>
-            <a:ext cx="548640" cy="548640"/>
+            <a:off x="9479128" y="1563624"/>
+            <a:ext cx="2011680" cy="310896"/>
           </a:xfrm>
           <a:prstGeom prst="rect">
             <a:avLst/>
@@ -3430,37 +3991,91 @@
           <a:ln/>
         </p:spPr>
         <p:txBody>
-          <a:bodyPr wrap="square" lIns="0" tIns="0" rIns="0" bIns="0" rtlCol="0" anchor="t"/>
-          <a:lstStyle/>
-          <a:p>
-            <a:pPr indent="0" marL="0">
+          <a:bodyPr wrap="square" lIns="0" tIns="0" rIns="0" bIns="0" rtlCol="0" anchor="ctr"/>
+          <a:lstStyle/>
+          <a:p>
+            <a:pPr algn="r" indent="0" marL="0">
               <a:buNone/>
             </a:pPr>
             <a:r>
-              <a:rPr lang="en-US" sz="2600" b="1" dirty="0">
+              <a:rPr lang="en-US" sz="1300" dirty="0">
                 <a:solidFill>
-                  <a:srgbClr val="12301A"/>
+                  <a:srgbClr val="FBFFF4"/>
                 </a:solidFill>
                 <a:latin typeface="Poppins" pitchFamily="34" charset="0"/>
                 <a:ea typeface="Poppins" pitchFamily="34" charset="-122"/>
                 <a:cs typeface="Poppins" pitchFamily="34" charset="-120"/>
               </a:rPr>
-              <a:t>?</a:t>
-            </a:r>
-            <a:endParaRPr lang="en-US" sz="2600" dirty="0"/>
-          </a:p>
-        </p:txBody>
-      </p:sp>
-      <p:sp>
-        <p:nvSpPr>
-          <p:cNvPr id="7" name="Text 4"/>
+              <a:t>Für dich</a:t>
+            </a:r>
+            <a:endParaRPr lang="en-US" sz="1300" dirty="0"/>
+          </a:p>
+        </p:txBody>
+      </p:sp>
+      <p:sp>
+        <p:nvSpPr>
+          <p:cNvPr id="7" name="Shape 4"/>
+          <p:cNvSpPr/>
+          <p:nvPr/>
+        </p:nvSpPr>
+        <p:spPr>
+          <a:xfrm>
+            <a:off x="8381848" y="1965960"/>
+            <a:ext cx="1920240" cy="411480"/>
+          </a:xfrm>
+          <a:prstGeom prst="roundRect">
+            <a:avLst>
+              <a:gd name="adj" fmla="val 17778"/>
+            </a:avLst>
+          </a:prstGeom>
+          <a:solidFill>
+            <a:srgbClr val="FBFFF4"/>
+          </a:solidFill>
+          <a:ln w="12700">
+            <a:solidFill>
+              <a:srgbClr val="FBFFF4"/>
+            </a:solidFill>
+            <a:prstDash val="solid"/>
+          </a:ln>
+        </p:spPr>
+      </p:sp>
+      <p:sp>
+        <p:nvSpPr>
+          <p:cNvPr id="8" name="Shape 5"/>
+          <p:cNvSpPr/>
+          <p:nvPr/>
+        </p:nvSpPr>
+        <p:spPr>
+          <a:xfrm>
+            <a:off x="8509864" y="2093976"/>
+            <a:ext cx="146304" cy="146304"/>
+          </a:xfrm>
+          <a:prstGeom prst="roundRect">
+            <a:avLst>
+              <a:gd name="adj" fmla="val 18750"/>
+            </a:avLst>
+          </a:prstGeom>
+          <a:solidFill>
+            <a:srgbClr val="DDF3B8"/>
+          </a:solidFill>
+          <a:ln w="6350">
+            <a:solidFill>
+              <a:srgbClr val="B8D98A"/>
+            </a:solidFill>
+            <a:prstDash val="solid"/>
+          </a:ln>
+        </p:spPr>
+      </p:sp>
+      <p:sp>
+        <p:nvSpPr>
+          <p:cNvPr id="9" name="Text 6"/>
           <p:cNvSpPr txBox="1"/>
           <p:nvPr/>
         </p:nvSpPr>
         <p:spPr>
           <a:xfrm>
-            <a:off x="8149133" y="1653235"/>
-            <a:ext cx="1114654" cy="578358"/>
+            <a:off x="8747608" y="1965960"/>
+            <a:ext cx="1508760" cy="411480"/>
           </a:xfrm>
           <a:prstGeom prst="rect">
             <a:avLst/>
@@ -3473,6 +4088,111 @@
           <a:lstStyle/>
           <a:p>
             <a:pPr indent="0" marL="0">
+              <a:buNone/>
+            </a:pPr>
+            <a:r>
+              <a:rPr lang="en-US" sz="1300" dirty="0">
+                <a:solidFill>
+                  <a:srgbClr val="0E1F0C"/>
+                </a:solidFill>
+                <a:latin typeface="Poppins" pitchFamily="34" charset="0"/>
+                <a:ea typeface="Poppins" pitchFamily="34" charset="-122"/>
+                <a:cs typeface="Poppins" pitchFamily="34" charset="-120"/>
+              </a:rPr>
+              <a:t>Dein Feed</a:t>
+            </a:r>
+            <a:endParaRPr lang="en-US" sz="1300" dirty="0"/>
+          </a:p>
+        </p:txBody>
+      </p:sp>
+      <p:sp>
+        <p:nvSpPr>
+          <p:cNvPr id="10" name="Text 7"/>
+          <p:cNvSpPr txBox="1"/>
+          <p:nvPr/>
+        </p:nvSpPr>
+        <p:spPr>
+          <a:xfrm>
+            <a:off x="8427568" y="2606040"/>
+            <a:ext cx="3017520" cy="457200"/>
+          </a:xfrm>
+          <a:prstGeom prst="rect">
+            <a:avLst/>
+          </a:prstGeom>
+          <a:noFill/>
+          <a:ln/>
+        </p:spPr>
+        <p:txBody>
+          <a:bodyPr wrap="square" lIns="0" tIns="0" rIns="0" bIns="0" rtlCol="0" anchor="t"/>
+          <a:lstStyle/>
+          <a:p>
+            <a:pPr indent="0" marL="0">
+              <a:buNone/>
+            </a:pPr>
+            <a:r>
+              <a:rPr lang="en-US" sz="2200" b="1" dirty="0">
+                <a:solidFill>
+                  <a:srgbClr val="0E1F0C"/>
+                </a:solidFill>
+                <a:latin typeface="Poppins" pitchFamily="34" charset="0"/>
+                <a:ea typeface="Poppins" pitchFamily="34" charset="-122"/>
+                <a:cs typeface="Poppins" pitchFamily="34" charset="-120"/>
+              </a:rPr>
+              <a:t>Dein Feed</a:t>
+            </a:r>
+            <a:endParaRPr lang="en-US" sz="2200" dirty="0"/>
+          </a:p>
+        </p:txBody>
+      </p:sp>
+      <p:sp>
+        <p:nvSpPr>
+          <p:cNvPr id="11" name="Shape 8"/>
+          <p:cNvSpPr/>
+          <p:nvPr/>
+        </p:nvSpPr>
+        <p:spPr>
+          <a:xfrm>
+            <a:off x="8427568" y="3200400"/>
+            <a:ext cx="1188720" cy="457200"/>
+          </a:xfrm>
+          <a:prstGeom prst="roundRect">
+            <a:avLst>
+              <a:gd name="adj" fmla="val 16000"/>
+            </a:avLst>
+          </a:prstGeom>
+          <a:solidFill>
+            <a:srgbClr val="B1FF37"/>
+          </a:solidFill>
+          <a:ln w="12700">
+            <a:solidFill>
+              <a:srgbClr val="B1FF37"/>
+            </a:solidFill>
+            <a:prstDash val="solid"/>
+          </a:ln>
+        </p:spPr>
+      </p:sp>
+      <p:sp>
+        <p:nvSpPr>
+          <p:cNvPr id="12" name="Text 9"/>
+          <p:cNvSpPr txBox="1"/>
+          <p:nvPr/>
+        </p:nvSpPr>
+        <p:spPr>
+          <a:xfrm>
+            <a:off x="8427568" y="3200400"/>
+            <a:ext cx="1188720" cy="457200"/>
+          </a:xfrm>
+          <a:prstGeom prst="rect">
+            <a:avLst/>
+          </a:prstGeom>
+          <a:noFill/>
+          <a:ln/>
+        </p:spPr>
+        <p:txBody>
+          <a:bodyPr wrap="square" lIns="0" tIns="0" rIns="0" bIns="0" rtlCol="0" anchor="ctr"/>
+          <a:lstStyle/>
+          <a:p>
+            <a:pPr algn="ctr" indent="0" marL="0">
               <a:buNone/>
             </a:pPr>
             <a:r>
@@ -3484,7 +4204,7 @@
                 <a:ea typeface="Poppins" pitchFamily="34" charset="-122"/>
                 <a:cs typeface="Poppins" pitchFamily="34" charset="-120"/>
               </a:rPr>
-              <a:t>Katzen?</a:t>
+              <a:t>Katzen</a:t>
             </a:r>
             <a:endParaRPr lang="en-US" sz="1400" dirty="0"/>
           </a:p>
@@ -3492,18 +4212,18 @@
       </p:sp>
       <p:sp>
         <p:nvSpPr>
-          <p:cNvPr id="8" name="Shape 5"/>
-          <p:cNvSpPr/>
-          <p:nvPr/>
-        </p:nvSpPr>
-        <p:spPr>
-          <a:xfrm>
-            <a:off x="8022946" y="2473452"/>
-            <a:ext cx="1367028" cy="1261872"/>
+          <p:cNvPr id="13" name="Shape 10"/>
+          <p:cNvSpPr/>
+          <p:nvPr/>
+        </p:nvSpPr>
+        <p:spPr>
+          <a:xfrm>
+            <a:off x="9753448" y="3200400"/>
+            <a:ext cx="1645920" cy="457200"/>
           </a:xfrm>
           <a:prstGeom prst="roundRect">
             <a:avLst>
-              <a:gd name="adj" fmla="val 8696"/>
+              <a:gd name="adj" fmla="val 16000"/>
             </a:avLst>
           </a:prstGeom>
           <a:solidFill>
@@ -3519,14 +4239,14 @@
       </p:sp>
       <p:sp>
         <p:nvSpPr>
-          <p:cNvPr id="9" name="Text 6"/>
+          <p:cNvPr id="14" name="Text 11"/>
           <p:cNvSpPr txBox="1"/>
           <p:nvPr/>
         </p:nvSpPr>
         <p:spPr>
           <a:xfrm>
-            <a:off x="8159648" y="2526030"/>
-            <a:ext cx="548640" cy="548640"/>
+            <a:off x="9753448" y="3200400"/>
+            <a:ext cx="1645920" cy="457200"/>
           </a:xfrm>
           <a:prstGeom prst="rect">
             <a:avLst/>
@@ -3535,49 +4255,10 @@
           <a:ln/>
         </p:spPr>
         <p:txBody>
-          <a:bodyPr wrap="square" lIns="0" tIns="0" rIns="0" bIns="0" rtlCol="0" anchor="t"/>
-          <a:lstStyle/>
-          <a:p>
-            <a:pPr indent="0" marL="0">
-              <a:buNone/>
-            </a:pPr>
-            <a:r>
-              <a:rPr lang="en-US" sz="2600" b="1" dirty="0">
-                <a:solidFill>
-                  <a:srgbClr val="12301A"/>
-                </a:solidFill>
-                <a:latin typeface="Poppins" pitchFamily="34" charset="0"/>
-                <a:ea typeface="Poppins" pitchFamily="34" charset="-122"/>
-                <a:cs typeface="Poppins" pitchFamily="34" charset="-120"/>
-              </a:rPr>
-              <a:t>?</a:t>
-            </a:r>
-            <a:endParaRPr lang="en-US" sz="2600" dirty="0"/>
-          </a:p>
-        </p:txBody>
-      </p:sp>
-      <p:sp>
-        <p:nvSpPr>
-          <p:cNvPr id="10" name="Text 7"/>
-          <p:cNvSpPr txBox="1"/>
-          <p:nvPr/>
-        </p:nvSpPr>
-        <p:spPr>
-          <a:xfrm>
-            <a:off x="8149133" y="3125419"/>
-            <a:ext cx="1114654" cy="578358"/>
-          </a:xfrm>
-          <a:prstGeom prst="rect">
-            <a:avLst/>
-          </a:prstGeom>
-          <a:noFill/>
-          <a:ln/>
-        </p:spPr>
-        <p:txBody>
           <a:bodyPr wrap="square" lIns="0" tIns="0" rIns="0" bIns="0" rtlCol="0" anchor="ctr"/>
           <a:lstStyle/>
           <a:p>
-            <a:pPr indent="0" marL="0">
+            <a:pPr algn="ctr" indent="0" marL="0">
               <a:buNone/>
             </a:pPr>
             <a:r>
@@ -3589,7 +4270,7 @@
                 <a:ea typeface="Poppins" pitchFamily="34" charset="-122"/>
                 <a:cs typeface="Poppins" pitchFamily="34" charset="-120"/>
               </a:rPr>
-              <a:t>Minecraft?</a:t>
+              <a:t>Minecraft</a:t>
             </a:r>
             <a:endParaRPr lang="en-US" sz="1400" dirty="0"/>
           </a:p>
@@ -3597,18 +4278,18 @@
       </p:sp>
       <p:sp>
         <p:nvSpPr>
-          <p:cNvPr id="11" name="Shape 8"/>
-          <p:cNvSpPr/>
-          <p:nvPr/>
-        </p:nvSpPr>
-        <p:spPr>
-          <a:xfrm>
-            <a:off x="8022946" y="3945636"/>
-            <a:ext cx="1367028" cy="1261872"/>
+          <p:cNvPr id="15" name="Shape 12"/>
+          <p:cNvSpPr/>
+          <p:nvPr/>
+        </p:nvSpPr>
+        <p:spPr>
+          <a:xfrm>
+            <a:off x="8427568" y="3794760"/>
+            <a:ext cx="1920240" cy="457200"/>
           </a:xfrm>
           <a:prstGeom prst="roundRect">
             <a:avLst>
-              <a:gd name="adj" fmla="val 8696"/>
+              <a:gd name="adj" fmla="val 16000"/>
             </a:avLst>
           </a:prstGeom>
           <a:solidFill>
@@ -3624,14 +4305,14 @@
       </p:sp>
       <p:sp>
         <p:nvSpPr>
-          <p:cNvPr id="12" name="Text 9"/>
+          <p:cNvPr id="16" name="Text 13"/>
           <p:cNvSpPr txBox="1"/>
           <p:nvPr/>
         </p:nvSpPr>
         <p:spPr>
           <a:xfrm>
-            <a:off x="8159648" y="3998214"/>
-            <a:ext cx="548640" cy="548640"/>
+            <a:off x="8427568" y="3794760"/>
+            <a:ext cx="1920240" cy="457200"/>
           </a:xfrm>
           <a:prstGeom prst="rect">
             <a:avLst/>
@@ -3640,49 +4321,10 @@
           <a:ln/>
         </p:spPr>
         <p:txBody>
-          <a:bodyPr wrap="square" lIns="0" tIns="0" rIns="0" bIns="0" rtlCol="0" anchor="t"/>
-          <a:lstStyle/>
-          <a:p>
-            <a:pPr indent="0" marL="0">
-              <a:buNone/>
-            </a:pPr>
-            <a:r>
-              <a:rPr lang="en-US" sz="2600" b="1" dirty="0">
-                <a:solidFill>
-                  <a:srgbClr val="12301A"/>
-                </a:solidFill>
-                <a:latin typeface="Poppins" pitchFamily="34" charset="0"/>
-                <a:ea typeface="Poppins" pitchFamily="34" charset="-122"/>
-                <a:cs typeface="Poppins" pitchFamily="34" charset="-120"/>
-              </a:rPr>
-              <a:t>?</a:t>
-            </a:r>
-            <a:endParaRPr lang="en-US" sz="2600" dirty="0"/>
-          </a:p>
-        </p:txBody>
-      </p:sp>
-      <p:sp>
-        <p:nvSpPr>
-          <p:cNvPr id="13" name="Text 10"/>
-          <p:cNvSpPr txBox="1"/>
-          <p:nvPr/>
-        </p:nvSpPr>
-        <p:spPr>
-          <a:xfrm>
-            <a:off x="8149133" y="4597603"/>
-            <a:ext cx="1114654" cy="578358"/>
-          </a:xfrm>
-          <a:prstGeom prst="rect">
-            <a:avLst/>
-          </a:prstGeom>
-          <a:noFill/>
-          <a:ln/>
-        </p:spPr>
-        <p:txBody>
           <a:bodyPr wrap="square" lIns="0" tIns="0" rIns="0" bIns="0" rtlCol="0" anchor="ctr"/>
           <a:lstStyle/>
           <a:p>
-            <a:pPr indent="0" marL="0">
+            <a:pPr algn="ctr" indent="0" marL="0">
               <a:buNone/>
             </a:pPr>
             <a:r>
@@ -3694,7 +4336,7 @@
                 <a:ea typeface="Poppins" pitchFamily="34" charset="-122"/>
                 <a:cs typeface="Poppins" pitchFamily="34" charset="-120"/>
               </a:rPr>
-              <a:t>Kochen?</a:t>
+              <a:t>Kochrezepte</a:t>
             </a:r>
             <a:endParaRPr lang="en-US" sz="1400" dirty="0"/>
           </a:p>
@@ -3702,14 +4344,14 @@
       </p:sp>
       <p:sp>
         <p:nvSpPr>
-          <p:cNvPr id="14" name="Text 11"/>
+          <p:cNvPr id="17" name="Text 14"/>
           <p:cNvSpPr txBox="1"/>
           <p:nvPr/>
         </p:nvSpPr>
         <p:spPr>
           <a:xfrm>
-            <a:off x="7629754" y="5811012"/>
-            <a:ext cx="2153412" cy="411480"/>
+            <a:off x="8427568" y="4754880"/>
+            <a:ext cx="3017520" cy="457200"/>
           </a:xfrm>
           <a:prstGeom prst="rect">
             <a:avLst/>
@@ -3721,21 +4363,21 @@
           <a:bodyPr wrap="square" lIns="0" tIns="0" rIns="0" bIns="0" rtlCol="0" anchor="t"/>
           <a:lstStyle/>
           <a:p>
-            <a:pPr algn="ctr" indent="0" marL="0">
+            <a:pPr indent="0" marL="0">
               <a:buNone/>
             </a:pPr>
             <a:r>
-              <a:rPr lang="en-US" sz="2000" b="1" dirty="0">
+              <a:rPr lang="en-US" sz="1400" dirty="0">
                 <a:solidFill>
-                  <a:srgbClr val="26720A"/>
+                  <a:srgbClr val="5B6B50"/>
                 </a:solidFill>
                 <a:latin typeface="Poppins" pitchFamily="34" charset="0"/>
                 <a:ea typeface="Poppins" pitchFamily="34" charset="-122"/>
                 <a:cs typeface="Poppins" pitchFamily="34" charset="-120"/>
               </a:rPr>
-              <a:t>Dein Feed</a:t>
-            </a:r>
-            <a:endParaRPr lang="en-US" sz="2000" dirty="0"/>
+              <a:t>Was zeigt dir die App – und warum?</a:t>
+            </a:r>
+            <a:endParaRPr lang="en-US" sz="1400" dirty="0"/>
           </a:p>
         </p:txBody>
       </p:sp>

</xml_diff>